<commit_message>
docs: fix explainer deck text overlap
</commit_message>
<xml_diff>
--- a/outputs/codemap-ctxdb-token-simulation.pptx
+++ b/outputs/codemap-ctxdb-token-simulation.pptx
@@ -2,20 +2,20 @@
 <file path=ppt/presentation.xml><?xml version="1.0" encoding="utf-8"?>
 <p:presentation xmlns:p="http://schemas.openxmlformats.org/presentationml/2006/main">
   <p:sldMasterIdLst>
-    <p:sldMasterId xmlns:r="http://schemas.openxmlformats.org/officeDocument/2006/relationships" id="2147483648" r:id="Rbda94ebee436468e"/>
+    <p:sldMasterId xmlns:r="http://schemas.openxmlformats.org/officeDocument/2006/relationships" id="2147483648" r:id="R40fde7e56ae04d42"/>
   </p:sldMasterIdLst>
   <p:notesMasterIdLst>
-    <p:notesMasterId xmlns:r="http://schemas.openxmlformats.org/officeDocument/2006/relationships" r:id="R7a3f8777722147ec"/>
+    <p:notesMasterId xmlns:r="http://schemas.openxmlformats.org/officeDocument/2006/relationships" r:id="R2a5cb03b94044455"/>
   </p:notesMasterIdLst>
   <p:sldIdLst>
-    <p:sldId xmlns:r="http://schemas.openxmlformats.org/officeDocument/2006/relationships" id="256" r:id="R5d48658f8cae488d"/>
-    <p:sldId xmlns:r="http://schemas.openxmlformats.org/officeDocument/2006/relationships" id="257" r:id="Rf9e1a5dda8ee4b0c"/>
-    <p:sldId xmlns:r="http://schemas.openxmlformats.org/officeDocument/2006/relationships" id="258" r:id="Rfeade5006b014252"/>
-    <p:sldId xmlns:r="http://schemas.openxmlformats.org/officeDocument/2006/relationships" id="259" r:id="R2df37afed9b843e9"/>
-    <p:sldId xmlns:r="http://schemas.openxmlformats.org/officeDocument/2006/relationships" id="260" r:id="R009aac51c8184d0a"/>
-    <p:sldId xmlns:r="http://schemas.openxmlformats.org/officeDocument/2006/relationships" id="261" r:id="Reaa335e2bba24b60"/>
-    <p:sldId xmlns:r="http://schemas.openxmlformats.org/officeDocument/2006/relationships" id="262" r:id="R04ed3371207a4e3d"/>
-    <p:sldId xmlns:r="http://schemas.openxmlformats.org/officeDocument/2006/relationships" id="263" r:id="R266fb376ae724a6d"/>
+    <p:sldId xmlns:r="http://schemas.openxmlformats.org/officeDocument/2006/relationships" id="256" r:id="R6eb00dd1784d4076"/>
+    <p:sldId xmlns:r="http://schemas.openxmlformats.org/officeDocument/2006/relationships" id="257" r:id="R71a9a8385da94787"/>
+    <p:sldId xmlns:r="http://schemas.openxmlformats.org/officeDocument/2006/relationships" id="258" r:id="R88351f1d398243e8"/>
+    <p:sldId xmlns:r="http://schemas.openxmlformats.org/officeDocument/2006/relationships" id="259" r:id="R580249db05b347fb"/>
+    <p:sldId xmlns:r="http://schemas.openxmlformats.org/officeDocument/2006/relationships" id="260" r:id="R40fa9d62c9d04374"/>
+    <p:sldId xmlns:r="http://schemas.openxmlformats.org/officeDocument/2006/relationships" id="261" r:id="R1a6eaeb292854130"/>
+    <p:sldId xmlns:r="http://schemas.openxmlformats.org/officeDocument/2006/relationships" id="262" r:id="Rbbf9e5f0ed18466f"/>
+    <p:sldId xmlns:r="http://schemas.openxmlformats.org/officeDocument/2006/relationships" id="263" r:id="R3ffe819712f7484c"/>
   </p:sldIdLst>
   <p:sldSz cx="12192000" cy="6858000"/>
   <p:notesSz cx="6858000" cy="9144000"/>
@@ -1070,7 +1070,7 @@
   </p:cSld>
   <p:clrMap bg1="lt1" tx1="dk1" bg2="lt2" tx2="dk2" accent1="accent1" accent2="accent2" accent3="accent3" accent4="accent4" accent5="accent5" accent6="accent6" hlink="hlink" folHlink="folHlink"/>
   <p:sldLayoutIdLst>
-    <p:sldLayoutId xmlns:r="http://schemas.openxmlformats.org/officeDocument/2006/relationships" id="2147483649" r:id="Rafbccafe82574e00"/>
+    <p:sldLayoutId xmlns:r="http://schemas.openxmlformats.org/officeDocument/2006/relationships" id="2147483649" r:id="Re2dd6abe5b56426b"/>
   </p:sldLayoutIdLst>
   <p:txStyles>
     <p:titleStyle>
@@ -1813,7 +1813,7 @@
           <p:cNvPr id="1" name="">
             <a:extLst xmlns:a="http://schemas.openxmlformats.org/drawingml/2006/main">
               <a:ext uri="{FF2B5EF4-FFF2-40B4-BE49-F238E27FC236}">
-                <a16:creationId xmlns:a16="http://schemas.microsoft.com/office/drawing/2014/main" id="{CDF59738-D211-4AD3-BD78-7B603A1CA783}"/>
+                <a16:creationId xmlns:a16="http://schemas.microsoft.com/office/drawing/2014/main" id="{5A11AA72-536E-4267-95A1-D55F581EA83D}"/>
               </a:ext>
             </a:extLst>
           </p:cNvPr>
@@ -1873,19 +1873,19 @@
           <p:cNvPr id="2" name="">
             <a:extLst xmlns:a="http://schemas.openxmlformats.org/drawingml/2006/main">
               <a:ext uri="{FF2B5EF4-FFF2-40B4-BE49-F238E27FC236}">
-                <a16:creationId xmlns:a16="http://schemas.microsoft.com/office/drawing/2014/main" id="{F7974172-7F0D-42C1-8A70-E0632054D696}"/>
-              </a:ext>
-            </a:extLst>
-          </p:cNvPr>
-          <p:cNvSpPr>
-            <a:spLocks xmlns:a="http://schemas.openxmlformats.org/drawingml/2006/main" noGrp="1"/>
-          </p:cNvSpPr>
-          <p:nvPr/>
-        </p:nvSpPr>
-        <p:spPr>
-          <a:xfrm xmlns:a="http://schemas.openxmlformats.org/drawingml/2006/main">
-            <a:off x="400050" y="1600200"/>
-            <a:ext cx="8572500" cy="1695450"/>
+                <a16:creationId xmlns:a16="http://schemas.microsoft.com/office/drawing/2014/main" id="{8D196083-86B0-4CF2-A487-B2F57448F8C8}"/>
+              </a:ext>
+            </a:extLst>
+          </p:cNvPr>
+          <p:cNvSpPr>
+            <a:spLocks xmlns:a="http://schemas.openxmlformats.org/drawingml/2006/main" noGrp="1"/>
+          </p:cNvSpPr>
+          <p:nvPr/>
+        </p:nvSpPr>
+        <p:spPr>
+          <a:xfrm xmlns:a="http://schemas.openxmlformats.org/drawingml/2006/main">
+            <a:off x="400050" y="1562100"/>
+            <a:ext cx="8191500" cy="1752600"/>
           </a:xfrm>
           <a:prstGeom xmlns:a="http://schemas.openxmlformats.org/drawingml/2006/main" prst="rect">
             <a:avLst/>
@@ -1902,10 +1902,10 @@
           <a:p xmlns:a="http://schemas.openxmlformats.org/drawingml/2006/main">
             <a:pPr algn="l">
               <a:lnSpc>
-                <a:spcPct val="102000"/>
-              </a:lnSpc>
-              <a:buNone/>
-              <a:defRPr sz="4350" b="1">
+                <a:spcPct val="105000"/>
+              </a:lnSpc>
+              <a:buNone/>
+              <a:defRPr sz="3900" b="1">
                 <a:solidFill>
                   <a:srgbClr val="000000"/>
                 </a:solidFill>
@@ -1915,7 +1915,7 @@
               </a:defRPr>
             </a:pPr>
             <a:r>
-              <a:rPr sz="4350" b="1">
+              <a:rPr sz="3900" b="1">
                 <a:solidFill>
                   <a:srgbClr val="000000"/>
                 </a:solidFill>
@@ -1933,7 +1933,7 @@
           <p:cNvPr id="3" name="">
             <a:extLst xmlns:a="http://schemas.openxmlformats.org/drawingml/2006/main">
               <a:ext uri="{FF2B5EF4-FFF2-40B4-BE49-F238E27FC236}">
-                <a16:creationId xmlns:a16="http://schemas.microsoft.com/office/drawing/2014/main" id="{D7516688-6961-4E72-879C-D251FC50DA0F}"/>
+                <a16:creationId xmlns:a16="http://schemas.microsoft.com/office/drawing/2014/main" id="{C3459731-8D6D-4BA9-B4B8-361312DFAF3F}"/>
               </a:ext>
             </a:extLst>
           </p:cNvPr>
@@ -1945,7 +1945,7 @@
         <p:spPr>
           <a:xfrm xmlns:a="http://schemas.openxmlformats.org/drawingml/2006/main">
             <a:off x="400050" y="3638550"/>
-            <a:ext cx="7239000" cy="685800"/>
+            <a:ext cx="7239000" cy="800100"/>
           </a:xfrm>
           <a:prstGeom xmlns:a="http://schemas.openxmlformats.org/drawingml/2006/main" prst="rect">
             <a:avLst/>
@@ -1965,17 +1965,17 @@
                 <a:spcPct val="122000"/>
               </a:lnSpc>
               <a:buNone/>
-              <a:defRPr sz="1800" b="0">
-                <a:solidFill>
-                  <a:srgbClr val="555555"/>
-                </a:solidFill>
-                <a:latin typeface="Malgun Gothic"/>
-                <a:ea typeface="Malgun Gothic"/>
-                <a:cs typeface="Malgun Gothic"/>
-              </a:defRPr>
-            </a:pPr>
-            <a:r>
-              <a:rPr sz="1800" b="0">
+              <a:defRPr sz="1575" b="0">
+                <a:solidFill>
+                  <a:srgbClr val="555555"/>
+                </a:solidFill>
+                <a:latin typeface="Malgun Gothic"/>
+                <a:ea typeface="Malgun Gothic"/>
+                <a:cs typeface="Malgun Gothic"/>
+              </a:defRPr>
+            </a:pPr>
+            <a:r>
+              <a:rPr sz="1575" b="0">
                 <a:solidFill>
                   <a:srgbClr val="555555"/>
                 </a:solidFill>
@@ -1993,7 +1993,7 @@
           <p:cNvPr id="4" name="">
             <a:extLst xmlns:a="http://schemas.openxmlformats.org/drawingml/2006/main">
               <a:ext uri="{FF2B5EF4-FFF2-40B4-BE49-F238E27FC236}">
-                <a16:creationId xmlns:a16="http://schemas.microsoft.com/office/drawing/2014/main" id="{6F2C9ED8-3647-4046-B35D-7A0C537119C6}"/>
+                <a16:creationId xmlns:a16="http://schemas.microsoft.com/office/drawing/2014/main" id="{46F3D625-8D17-4E5C-A33F-CA06E213AF09}"/>
               </a:ext>
             </a:extLst>
           </p:cNvPr>
@@ -2024,7 +2024,7 @@
           <p:cNvPr id="5" name="">
             <a:extLst xmlns:a="http://schemas.openxmlformats.org/drawingml/2006/main">
               <a:ext uri="{FF2B5EF4-FFF2-40B4-BE49-F238E27FC236}">
-                <a16:creationId xmlns:a16="http://schemas.microsoft.com/office/drawing/2014/main" id="{C19A5183-02D9-49F9-99EC-87242ABFFCFD}"/>
+                <a16:creationId xmlns:a16="http://schemas.microsoft.com/office/drawing/2014/main" id="{E9EC1501-B492-4F08-AB6F-7806CF7741F5}"/>
               </a:ext>
             </a:extLst>
           </p:cNvPr>
@@ -2084,7 +2084,7 @@
           <p:cNvPr id="6" name="">
             <a:extLst xmlns:a="http://schemas.openxmlformats.org/drawingml/2006/main">
               <a:ext uri="{FF2B5EF4-FFF2-40B4-BE49-F238E27FC236}">
-                <a16:creationId xmlns:a16="http://schemas.microsoft.com/office/drawing/2014/main" id="{EDEECD22-FDE1-43F6-A1E1-BCCD3C99D9A7}"/>
+                <a16:creationId xmlns:a16="http://schemas.microsoft.com/office/drawing/2014/main" id="{48802D31-312B-416F-8790-4F4FB8DCA43A}"/>
               </a:ext>
             </a:extLst>
           </p:cNvPr>
@@ -2144,7 +2144,7 @@
           <p:cNvPr id="7" name="">
             <a:extLst xmlns:a="http://schemas.openxmlformats.org/drawingml/2006/main">
               <a:ext uri="{FF2B5EF4-FFF2-40B4-BE49-F238E27FC236}">
-                <a16:creationId xmlns:a16="http://schemas.microsoft.com/office/drawing/2014/main" id="{3B4EAE6B-4036-4DB8-9784-7E86FF09D44C}"/>
+                <a16:creationId xmlns:a16="http://schemas.microsoft.com/office/drawing/2014/main" id="{BA298014-4BA2-44AC-B020-74D70B719563}"/>
               </a:ext>
             </a:extLst>
           </p:cNvPr>
@@ -2175,7 +2175,7 @@
           <p:cNvPr id="8" name="">
             <a:extLst xmlns:a="http://schemas.openxmlformats.org/drawingml/2006/main">
               <a:ext uri="{FF2B5EF4-FFF2-40B4-BE49-F238E27FC236}">
-                <a16:creationId xmlns:a16="http://schemas.microsoft.com/office/drawing/2014/main" id="{2C8D60FF-76DB-4E57-9452-82A74C505626}"/>
+                <a16:creationId xmlns:a16="http://schemas.microsoft.com/office/drawing/2014/main" id="{EC698183-3BB7-44AC-AE20-9200CAED5708}"/>
               </a:ext>
             </a:extLst>
           </p:cNvPr>
@@ -2235,7 +2235,7 @@
           <p:cNvPr id="9" name="">
             <a:extLst xmlns:a="http://schemas.openxmlformats.org/drawingml/2006/main">
               <a:ext uri="{FF2B5EF4-FFF2-40B4-BE49-F238E27FC236}">
-                <a16:creationId xmlns:a16="http://schemas.microsoft.com/office/drawing/2014/main" id="{60C55CEE-3E38-434F-8B62-08F1F45E3705}"/>
+                <a16:creationId xmlns:a16="http://schemas.microsoft.com/office/drawing/2014/main" id="{B8C5ABA3-0CB1-40AB-8461-1791795F3731}"/>
               </a:ext>
             </a:extLst>
           </p:cNvPr>
@@ -2295,7 +2295,7 @@
           <p:cNvPr id="10" name="">
             <a:extLst xmlns:a="http://schemas.openxmlformats.org/drawingml/2006/main">
               <a:ext uri="{FF2B5EF4-FFF2-40B4-BE49-F238E27FC236}">
-                <a16:creationId xmlns:a16="http://schemas.microsoft.com/office/drawing/2014/main" id="{B952DEBC-E951-4F82-9545-3DAF2D1B2BA2}"/>
+                <a16:creationId xmlns:a16="http://schemas.microsoft.com/office/drawing/2014/main" id="{6214797F-5DFE-422B-B7A8-E16C2EECE8F2}"/>
               </a:ext>
             </a:extLst>
           </p:cNvPr>
@@ -2326,7 +2326,7 @@
           <p:cNvPr id="11" name="">
             <a:extLst xmlns:a="http://schemas.openxmlformats.org/drawingml/2006/main">
               <a:ext uri="{FF2B5EF4-FFF2-40B4-BE49-F238E27FC236}">
-                <a16:creationId xmlns:a16="http://schemas.microsoft.com/office/drawing/2014/main" id="{1ACAB3B3-68EF-441C-8808-A4534579E79F}"/>
+                <a16:creationId xmlns:a16="http://schemas.microsoft.com/office/drawing/2014/main" id="{E9FBD091-F315-4610-A714-E06AC7E9CF95}"/>
               </a:ext>
             </a:extLst>
           </p:cNvPr>
@@ -2386,7 +2386,7 @@
           <p:cNvPr id="12" name="">
             <a:extLst xmlns:a="http://schemas.openxmlformats.org/drawingml/2006/main">
               <a:ext uri="{FF2B5EF4-FFF2-40B4-BE49-F238E27FC236}">
-                <a16:creationId xmlns:a16="http://schemas.microsoft.com/office/drawing/2014/main" id="{EA16C091-4D7E-4FDE-AD1C-8A8839085EC0}"/>
+                <a16:creationId xmlns:a16="http://schemas.microsoft.com/office/drawing/2014/main" id="{CB08D7DA-238C-41E6-8954-557C46E3A372}"/>
               </a:ext>
             </a:extLst>
           </p:cNvPr>
@@ -2446,7 +2446,7 @@
           <p:cNvPr id="13" name="">
             <a:extLst xmlns:a="http://schemas.openxmlformats.org/drawingml/2006/main">
               <a:ext uri="{FF2B5EF4-FFF2-40B4-BE49-F238E27FC236}">
-                <a16:creationId xmlns:a16="http://schemas.microsoft.com/office/drawing/2014/main" id="{62EF3FFB-E47C-4F9A-9D32-661088759E13}"/>
+                <a16:creationId xmlns:a16="http://schemas.microsoft.com/office/drawing/2014/main" id="{0769A42D-8469-42F5-B40E-4614614A1E81}"/>
               </a:ext>
             </a:extLst>
           </p:cNvPr>
@@ -2477,7 +2477,7 @@
           <p:cNvPr id="14" name="">
             <a:extLst xmlns:a="http://schemas.openxmlformats.org/drawingml/2006/main">
               <a:ext uri="{FF2B5EF4-FFF2-40B4-BE49-F238E27FC236}">
-                <a16:creationId xmlns:a16="http://schemas.microsoft.com/office/drawing/2014/main" id="{2328CBE4-37A4-4882-A91C-4EB034C3CF58}"/>
+                <a16:creationId xmlns:a16="http://schemas.microsoft.com/office/drawing/2014/main" id="{41469F7D-54F6-45C8-8178-5D0C6A857CD3}"/>
               </a:ext>
             </a:extLst>
           </p:cNvPr>
@@ -2537,7 +2537,7 @@
           <p:cNvPr id="15" name="">
             <a:extLst xmlns:a="http://schemas.openxmlformats.org/drawingml/2006/main">
               <a:ext uri="{FF2B5EF4-FFF2-40B4-BE49-F238E27FC236}">
-                <a16:creationId xmlns:a16="http://schemas.microsoft.com/office/drawing/2014/main" id="{BE94BDF9-455B-49EA-8B37-539F5D9E36FD}"/>
+                <a16:creationId xmlns:a16="http://schemas.microsoft.com/office/drawing/2014/main" id="{A8690CEB-6BD1-4AA6-B870-D08A3C264F27}"/>
               </a:ext>
             </a:extLst>
           </p:cNvPr>
@@ -2595,7 +2595,7 @@
     </p:spTree>
     <p:extLst>
       <p:ext uri="{BB962C8B-B14F-4D97-AF65-F5344CB8AC3E}">
-        <p14:creationId xmlns:p14="http://schemas.microsoft.com/office/powerpoint/2010/main" val="2131960562"/>
+        <p14:creationId xmlns:p14="http://schemas.microsoft.com/office/powerpoint/2010/main" val="1543655770"/>
       </p:ext>
     </p:extLst>
   </p:cSld>
@@ -2626,7 +2626,7 @@
           <p:cNvPr id="1" name="">
             <a:extLst xmlns:a="http://schemas.openxmlformats.org/drawingml/2006/main">
               <a:ext uri="{FF2B5EF4-FFF2-40B4-BE49-F238E27FC236}">
-                <a16:creationId xmlns:a16="http://schemas.microsoft.com/office/drawing/2014/main" id="{D22EB23F-EDF9-4C1A-A852-1B25D5705A4A}"/>
+                <a16:creationId xmlns:a16="http://schemas.microsoft.com/office/drawing/2014/main" id="{BD827338-9313-4F0E-AC02-978130D7BD67}"/>
               </a:ext>
             </a:extLst>
           </p:cNvPr>
@@ -2686,7 +2686,7 @@
           <p:cNvPr id="2" name="">
             <a:extLst xmlns:a="http://schemas.openxmlformats.org/drawingml/2006/main">
               <a:ext uri="{FF2B5EF4-FFF2-40B4-BE49-F238E27FC236}">
-                <a16:creationId xmlns:a16="http://schemas.microsoft.com/office/drawing/2014/main" id="{0827DD09-8D82-4F19-AB60-99E71545F0AD}"/>
+                <a16:creationId xmlns:a16="http://schemas.microsoft.com/office/drawing/2014/main" id="{AA139C55-A486-4E97-BA3E-CCCD29676C9A}"/>
               </a:ext>
             </a:extLst>
           </p:cNvPr>
@@ -2698,7 +2698,7 @@
         <p:spPr>
           <a:xfrm xmlns:a="http://schemas.openxmlformats.org/drawingml/2006/main">
             <a:off x="400050" y="742950"/>
-            <a:ext cx="8858250" cy="1123950"/>
+            <a:ext cx="8572500" cy="1238250"/>
           </a:xfrm>
           <a:prstGeom xmlns:a="http://schemas.openxmlformats.org/drawingml/2006/main" prst="rect">
             <a:avLst/>
@@ -2715,10 +2715,10 @@
           <a:p xmlns:a="http://schemas.openxmlformats.org/drawingml/2006/main">
             <a:pPr algn="l">
               <a:lnSpc>
-                <a:spcPct val="102000"/>
-              </a:lnSpc>
-              <a:buNone/>
-              <a:defRPr sz="3600" b="1">
+                <a:spcPct val="105000"/>
+              </a:lnSpc>
+              <a:buNone/>
+              <a:defRPr sz="3150" b="1">
                 <a:solidFill>
                   <a:srgbClr val="000000"/>
                 </a:solidFill>
@@ -2728,7 +2728,7 @@
               </a:defRPr>
             </a:pPr>
             <a:r>
-              <a:rPr sz="3600" b="1">
+              <a:rPr sz="3150" b="1">
                 <a:solidFill>
                   <a:srgbClr val="000000"/>
                 </a:solidFill>
@@ -2746,19 +2746,19 @@
           <p:cNvPr id="3" name="">
             <a:extLst xmlns:a="http://schemas.openxmlformats.org/drawingml/2006/main">
               <a:ext uri="{FF2B5EF4-FFF2-40B4-BE49-F238E27FC236}">
-                <a16:creationId xmlns:a16="http://schemas.microsoft.com/office/drawing/2014/main" id="{126A4CD2-4E6F-4AE5-9B9C-65A429C61BBB}"/>
-              </a:ext>
-            </a:extLst>
-          </p:cNvPr>
-          <p:cNvSpPr>
-            <a:spLocks xmlns:a="http://schemas.openxmlformats.org/drawingml/2006/main" noGrp="1"/>
-          </p:cNvSpPr>
-          <p:nvPr/>
-        </p:nvSpPr>
-        <p:spPr>
-          <a:xfrm xmlns:a="http://schemas.openxmlformats.org/drawingml/2006/main">
-            <a:off x="400050" y="1943100"/>
-            <a:ext cx="7239000" cy="609600"/>
+                <a16:creationId xmlns:a16="http://schemas.microsoft.com/office/drawing/2014/main" id="{71E82E87-6706-4802-A777-118446AD311A}"/>
+              </a:ext>
+            </a:extLst>
+          </p:cNvPr>
+          <p:cNvSpPr>
+            <a:spLocks xmlns:a="http://schemas.openxmlformats.org/drawingml/2006/main" noGrp="1"/>
+          </p:cNvSpPr>
+          <p:nvPr/>
+        </p:nvSpPr>
+        <p:spPr>
+          <a:xfrm xmlns:a="http://schemas.openxmlformats.org/drawingml/2006/main">
+            <a:off x="400050" y="2076450"/>
+            <a:ext cx="7620000" cy="590550"/>
           </a:xfrm>
           <a:prstGeom xmlns:a="http://schemas.openxmlformats.org/drawingml/2006/main" prst="rect">
             <a:avLst/>
@@ -2775,20 +2775,20 @@
           <a:p xmlns:a="http://schemas.openxmlformats.org/drawingml/2006/main">
             <a:pPr algn="l">
               <a:lnSpc>
-                <a:spcPct val="125000"/>
-              </a:lnSpc>
-              <a:buNone/>
-              <a:defRPr sz="1650" b="0">
-                <a:solidFill>
-                  <a:srgbClr val="555555"/>
-                </a:solidFill>
-                <a:latin typeface="Malgun Gothic"/>
-                <a:ea typeface="Malgun Gothic"/>
-                <a:cs typeface="Malgun Gothic"/>
-              </a:defRPr>
-            </a:pPr>
-            <a:r>
-              <a:rPr sz="1650" b="0">
+                <a:spcPct val="122000"/>
+              </a:lnSpc>
+              <a:buNone/>
+              <a:defRPr sz="1500" b="0">
+                <a:solidFill>
+                  <a:srgbClr val="555555"/>
+                </a:solidFill>
+                <a:latin typeface="Malgun Gothic"/>
+                <a:ea typeface="Malgun Gothic"/>
+                <a:cs typeface="Malgun Gothic"/>
+              </a:defRPr>
+            </a:pPr>
+            <a:r>
+              <a:rPr sz="1500" b="0">
                 <a:solidFill>
                   <a:srgbClr val="555555"/>
                 </a:solidFill>
@@ -2806,7 +2806,7 @@
           <p:cNvPr id="4" name="">
             <a:extLst xmlns:a="http://schemas.openxmlformats.org/drawingml/2006/main">
               <a:ext uri="{FF2B5EF4-FFF2-40B4-BE49-F238E27FC236}">
-                <a16:creationId xmlns:a16="http://schemas.microsoft.com/office/drawing/2014/main" id="{3FB4D618-4C18-42B8-9709-DD346F84CD18}"/>
+                <a16:creationId xmlns:a16="http://schemas.microsoft.com/office/drawing/2014/main" id="{1292BCCE-FF83-467A-9FE3-B592DFEB74DB}"/>
               </a:ext>
             </a:extLst>
           </p:cNvPr>
@@ -2866,7 +2866,7 @@
           <p:cNvPr id="5" name="">
             <a:extLst xmlns:a="http://schemas.openxmlformats.org/drawingml/2006/main">
               <a:ext uri="{FF2B5EF4-FFF2-40B4-BE49-F238E27FC236}">
-                <a16:creationId xmlns:a16="http://schemas.microsoft.com/office/drawing/2014/main" id="{80E7CB6C-F3C7-4453-AF61-23DED4474225}"/>
+                <a16:creationId xmlns:a16="http://schemas.microsoft.com/office/drawing/2014/main" id="{FBA2CD43-3E5F-4811-A6DF-93A70240673C}"/>
               </a:ext>
             </a:extLst>
           </p:cNvPr>
@@ -2897,7 +2897,7 @@
           <p:cNvPr id="6" name="">
             <a:extLst xmlns:a="http://schemas.openxmlformats.org/drawingml/2006/main">
               <a:ext uri="{FF2B5EF4-FFF2-40B4-BE49-F238E27FC236}">
-                <a16:creationId xmlns:a16="http://schemas.microsoft.com/office/drawing/2014/main" id="{EAD2F226-F401-402C-A09B-7D3B8E4B15E8}"/>
+                <a16:creationId xmlns:a16="http://schemas.microsoft.com/office/drawing/2014/main" id="{E423985E-AFD1-47D5-835C-8911A4BDED40}"/>
               </a:ext>
             </a:extLst>
           </p:cNvPr>
@@ -2928,7 +2928,7 @@
           <p:cNvPr id="7" name="">
             <a:extLst xmlns:a="http://schemas.openxmlformats.org/drawingml/2006/main">
               <a:ext uri="{FF2B5EF4-FFF2-40B4-BE49-F238E27FC236}">
-                <a16:creationId xmlns:a16="http://schemas.microsoft.com/office/drawing/2014/main" id="{9EB0E016-1D74-4C5F-AB0F-F92FCAB93300}"/>
+                <a16:creationId xmlns:a16="http://schemas.microsoft.com/office/drawing/2014/main" id="{4A5EAD9F-B6D2-459D-B9D2-369288A05378}"/>
               </a:ext>
             </a:extLst>
           </p:cNvPr>
@@ -2959,7 +2959,7 @@
           <p:cNvPr id="8" name="">
             <a:extLst xmlns:a="http://schemas.openxmlformats.org/drawingml/2006/main">
               <a:ext uri="{FF2B5EF4-FFF2-40B4-BE49-F238E27FC236}">
-                <a16:creationId xmlns:a16="http://schemas.microsoft.com/office/drawing/2014/main" id="{819500BF-4E76-4058-966C-64CB604FCD98}"/>
+                <a16:creationId xmlns:a16="http://schemas.microsoft.com/office/drawing/2014/main" id="{65CE3581-B24F-45A6-9938-A11F04BE84DD}"/>
               </a:ext>
             </a:extLst>
           </p:cNvPr>
@@ -3019,7 +3019,7 @@
           <p:cNvPr id="9" name="">
             <a:extLst xmlns:a="http://schemas.openxmlformats.org/drawingml/2006/main">
               <a:ext uri="{FF2B5EF4-FFF2-40B4-BE49-F238E27FC236}">
-                <a16:creationId xmlns:a16="http://schemas.microsoft.com/office/drawing/2014/main" id="{B1DC7DF8-C494-43BF-94A6-E867BB873960}"/>
+                <a16:creationId xmlns:a16="http://schemas.microsoft.com/office/drawing/2014/main" id="{E065E96D-E52E-4C61-BBF5-1A3B8E9C07A7}"/>
               </a:ext>
             </a:extLst>
           </p:cNvPr>
@@ -3079,7 +3079,7 @@
           <p:cNvPr id="10" name="">
             <a:extLst xmlns:a="http://schemas.openxmlformats.org/drawingml/2006/main">
               <a:ext uri="{FF2B5EF4-FFF2-40B4-BE49-F238E27FC236}">
-                <a16:creationId xmlns:a16="http://schemas.microsoft.com/office/drawing/2014/main" id="{AD2F1F52-DC40-4E25-85F8-210155615718}"/>
+                <a16:creationId xmlns:a16="http://schemas.microsoft.com/office/drawing/2014/main" id="{4192954F-77E0-4AC1-A666-F14AE1854004}"/>
               </a:ext>
             </a:extLst>
           </p:cNvPr>
@@ -3139,7 +3139,7 @@
           <p:cNvPr id="11" name="">
             <a:extLst xmlns:a="http://schemas.openxmlformats.org/drawingml/2006/main">
               <a:ext uri="{FF2B5EF4-FFF2-40B4-BE49-F238E27FC236}">
-                <a16:creationId xmlns:a16="http://schemas.microsoft.com/office/drawing/2014/main" id="{05371DA3-508A-44B8-9EF1-84121C2818A5}"/>
+                <a16:creationId xmlns:a16="http://schemas.microsoft.com/office/drawing/2014/main" id="{65346A58-B626-476A-9DA0-1CE9C9F9E641}"/>
               </a:ext>
             </a:extLst>
           </p:cNvPr>
@@ -3199,7 +3199,7 @@
           <p:cNvPr id="12" name="">
             <a:extLst xmlns:a="http://schemas.openxmlformats.org/drawingml/2006/main">
               <a:ext uri="{FF2B5EF4-FFF2-40B4-BE49-F238E27FC236}">
-                <a16:creationId xmlns:a16="http://schemas.microsoft.com/office/drawing/2014/main" id="{F55D797A-E601-4EEF-8C03-C26CCACA4D7D}"/>
+                <a16:creationId xmlns:a16="http://schemas.microsoft.com/office/drawing/2014/main" id="{64144CD1-F0C6-47A7-BA6A-E45D62F4B497}"/>
               </a:ext>
             </a:extLst>
           </p:cNvPr>
@@ -3259,7 +3259,7 @@
           <p:cNvPr id="13" name="">
             <a:extLst xmlns:a="http://schemas.openxmlformats.org/drawingml/2006/main">
               <a:ext uri="{FF2B5EF4-FFF2-40B4-BE49-F238E27FC236}">
-                <a16:creationId xmlns:a16="http://schemas.microsoft.com/office/drawing/2014/main" id="{9005DD9C-EB58-42B3-9461-97B5D91775B0}"/>
+                <a16:creationId xmlns:a16="http://schemas.microsoft.com/office/drawing/2014/main" id="{A09B48C7-C325-4717-A412-CEB6328A9ECC}"/>
               </a:ext>
             </a:extLst>
           </p:cNvPr>
@@ -3319,7 +3319,7 @@
           <p:cNvPr id="14" name="">
             <a:extLst xmlns:a="http://schemas.openxmlformats.org/drawingml/2006/main">
               <a:ext uri="{FF2B5EF4-FFF2-40B4-BE49-F238E27FC236}">
-                <a16:creationId xmlns:a16="http://schemas.microsoft.com/office/drawing/2014/main" id="{B0C874E5-F5D5-4681-927A-4EDED00541F0}"/>
+                <a16:creationId xmlns:a16="http://schemas.microsoft.com/office/drawing/2014/main" id="{95EAFFA9-C2E2-4187-8F44-DFE628D5CCE0}"/>
               </a:ext>
             </a:extLst>
           </p:cNvPr>
@@ -3379,7 +3379,7 @@
           <p:cNvPr id="15" name="">
             <a:extLst xmlns:a="http://schemas.openxmlformats.org/drawingml/2006/main">
               <a:ext uri="{FF2B5EF4-FFF2-40B4-BE49-F238E27FC236}">
-                <a16:creationId xmlns:a16="http://schemas.microsoft.com/office/drawing/2014/main" id="{3208840E-B0BB-4B48-AA3B-2C584E95A2A2}"/>
+                <a16:creationId xmlns:a16="http://schemas.microsoft.com/office/drawing/2014/main" id="{9D130E71-60C0-41E4-A216-067695A7C471}"/>
               </a:ext>
             </a:extLst>
           </p:cNvPr>
@@ -3439,7 +3439,7 @@
           <p:cNvPr id="16" name="">
             <a:extLst xmlns:a="http://schemas.openxmlformats.org/drawingml/2006/main">
               <a:ext uri="{FF2B5EF4-FFF2-40B4-BE49-F238E27FC236}">
-                <a16:creationId xmlns:a16="http://schemas.microsoft.com/office/drawing/2014/main" id="{4B0B9A76-146A-477F-9876-6E85DE44F018}"/>
+                <a16:creationId xmlns:a16="http://schemas.microsoft.com/office/drawing/2014/main" id="{6B9012D9-6D5D-453F-9C1C-4262CAB7F7FB}"/>
               </a:ext>
             </a:extLst>
           </p:cNvPr>
@@ -3499,7 +3499,7 @@
           <p:cNvPr id="17" name="">
             <a:extLst xmlns:a="http://schemas.openxmlformats.org/drawingml/2006/main">
               <a:ext uri="{FF2B5EF4-FFF2-40B4-BE49-F238E27FC236}">
-                <a16:creationId xmlns:a16="http://schemas.microsoft.com/office/drawing/2014/main" id="{7F988D26-6384-4088-997A-464F4A5A9FB3}"/>
+                <a16:creationId xmlns:a16="http://schemas.microsoft.com/office/drawing/2014/main" id="{95F88F94-8DC3-4C1D-B863-083AFF67FE7B}"/>
               </a:ext>
             </a:extLst>
           </p:cNvPr>
@@ -3530,7 +3530,7 @@
           <p:cNvPr id="18" name="">
             <a:extLst xmlns:a="http://schemas.openxmlformats.org/drawingml/2006/main">
               <a:ext uri="{FF2B5EF4-FFF2-40B4-BE49-F238E27FC236}">
-                <a16:creationId xmlns:a16="http://schemas.microsoft.com/office/drawing/2014/main" id="{07B85988-C432-40D8-9F23-C41DC5FEF85B}"/>
+                <a16:creationId xmlns:a16="http://schemas.microsoft.com/office/drawing/2014/main" id="{F686749F-E70A-40DF-9483-C7A4B8238CD3}"/>
               </a:ext>
             </a:extLst>
           </p:cNvPr>
@@ -3590,7 +3590,7 @@
           <p:cNvPr id="19" name="">
             <a:extLst xmlns:a="http://schemas.openxmlformats.org/drawingml/2006/main">
               <a:ext uri="{FF2B5EF4-FFF2-40B4-BE49-F238E27FC236}">
-                <a16:creationId xmlns:a16="http://schemas.microsoft.com/office/drawing/2014/main" id="{DA456A6C-260D-4EE3-BC62-300DA9782C59}"/>
+                <a16:creationId xmlns:a16="http://schemas.microsoft.com/office/drawing/2014/main" id="{B385F31E-99AF-4D5F-90A4-E8BD2341D12A}"/>
               </a:ext>
             </a:extLst>
           </p:cNvPr>
@@ -3648,7 +3648,7 @@
     </p:spTree>
     <p:extLst>
       <p:ext uri="{BB962C8B-B14F-4D97-AF65-F5344CB8AC3E}">
-        <p14:creationId xmlns:p14="http://schemas.microsoft.com/office/powerpoint/2010/main" val="37925852"/>
+        <p14:creationId xmlns:p14="http://schemas.microsoft.com/office/powerpoint/2010/main" val="1838065814"/>
       </p:ext>
     </p:extLst>
   </p:cSld>
@@ -3679,7 +3679,7 @@
           <p:cNvPr id="1" name="">
             <a:extLst xmlns:a="http://schemas.openxmlformats.org/drawingml/2006/main">
               <a:ext uri="{FF2B5EF4-FFF2-40B4-BE49-F238E27FC236}">
-                <a16:creationId xmlns:a16="http://schemas.microsoft.com/office/drawing/2014/main" id="{18B3035B-BCA3-4476-843A-72714CFF9CDA}"/>
+                <a16:creationId xmlns:a16="http://schemas.microsoft.com/office/drawing/2014/main" id="{A571117B-A549-4E23-A2E3-2029F63E9B51}"/>
               </a:ext>
             </a:extLst>
           </p:cNvPr>
@@ -3739,7 +3739,7 @@
           <p:cNvPr id="2" name="">
             <a:extLst xmlns:a="http://schemas.openxmlformats.org/drawingml/2006/main">
               <a:ext uri="{FF2B5EF4-FFF2-40B4-BE49-F238E27FC236}">
-                <a16:creationId xmlns:a16="http://schemas.microsoft.com/office/drawing/2014/main" id="{6B3C2FAB-F3EA-4A70-A2AD-A06F12364187}"/>
+                <a16:creationId xmlns:a16="http://schemas.microsoft.com/office/drawing/2014/main" id="{F8D91AA6-4812-4CED-9EAB-63DC41191684}"/>
               </a:ext>
             </a:extLst>
           </p:cNvPr>
@@ -3751,7 +3751,7 @@
         <p:spPr>
           <a:xfrm xmlns:a="http://schemas.openxmlformats.org/drawingml/2006/main">
             <a:off x="400050" y="742950"/>
-            <a:ext cx="8858250" cy="1123950"/>
+            <a:ext cx="8572500" cy="1238250"/>
           </a:xfrm>
           <a:prstGeom xmlns:a="http://schemas.openxmlformats.org/drawingml/2006/main" prst="rect">
             <a:avLst/>
@@ -3768,10 +3768,10 @@
           <a:p xmlns:a="http://schemas.openxmlformats.org/drawingml/2006/main">
             <a:pPr algn="l">
               <a:lnSpc>
-                <a:spcPct val="102000"/>
-              </a:lnSpc>
-              <a:buNone/>
-              <a:defRPr sz="3600" b="1">
+                <a:spcPct val="105000"/>
+              </a:lnSpc>
+              <a:buNone/>
+              <a:defRPr sz="3150" b="1">
                 <a:solidFill>
                   <a:srgbClr val="000000"/>
                 </a:solidFill>
@@ -3781,7 +3781,7 @@
               </a:defRPr>
             </a:pPr>
             <a:r>
-              <a:rPr sz="3600" b="1">
+              <a:rPr sz="3150" b="1">
                 <a:solidFill>
                   <a:srgbClr val="000000"/>
                 </a:solidFill>
@@ -3799,19 +3799,19 @@
           <p:cNvPr id="3" name="">
             <a:extLst xmlns:a="http://schemas.openxmlformats.org/drawingml/2006/main">
               <a:ext uri="{FF2B5EF4-FFF2-40B4-BE49-F238E27FC236}">
-                <a16:creationId xmlns:a16="http://schemas.microsoft.com/office/drawing/2014/main" id="{8D34B78E-2597-46E4-8970-74B5B183BEE4}"/>
-              </a:ext>
-            </a:extLst>
-          </p:cNvPr>
-          <p:cNvSpPr>
-            <a:spLocks xmlns:a="http://schemas.openxmlformats.org/drawingml/2006/main" noGrp="1"/>
-          </p:cNvSpPr>
-          <p:nvPr/>
-        </p:nvSpPr>
-        <p:spPr>
-          <a:xfrm xmlns:a="http://schemas.openxmlformats.org/drawingml/2006/main">
-            <a:off x="400050" y="1943100"/>
-            <a:ext cx="7239000" cy="609600"/>
+                <a16:creationId xmlns:a16="http://schemas.microsoft.com/office/drawing/2014/main" id="{C7EEE748-076E-4021-AC3D-DB71521EC881}"/>
+              </a:ext>
+            </a:extLst>
+          </p:cNvPr>
+          <p:cNvSpPr>
+            <a:spLocks xmlns:a="http://schemas.openxmlformats.org/drawingml/2006/main" noGrp="1"/>
+          </p:cNvSpPr>
+          <p:nvPr/>
+        </p:nvSpPr>
+        <p:spPr>
+          <a:xfrm xmlns:a="http://schemas.openxmlformats.org/drawingml/2006/main">
+            <a:off x="400050" y="2076450"/>
+            <a:ext cx="7620000" cy="590550"/>
           </a:xfrm>
           <a:prstGeom xmlns:a="http://schemas.openxmlformats.org/drawingml/2006/main" prst="rect">
             <a:avLst/>
@@ -3828,20 +3828,20 @@
           <a:p xmlns:a="http://schemas.openxmlformats.org/drawingml/2006/main">
             <a:pPr algn="l">
               <a:lnSpc>
-                <a:spcPct val="125000"/>
-              </a:lnSpc>
-              <a:buNone/>
-              <a:defRPr sz="1650" b="0">
-                <a:solidFill>
-                  <a:srgbClr val="555555"/>
-                </a:solidFill>
-                <a:latin typeface="Malgun Gothic"/>
-                <a:ea typeface="Malgun Gothic"/>
-                <a:cs typeface="Malgun Gothic"/>
-              </a:defRPr>
-            </a:pPr>
-            <a:r>
-              <a:rPr sz="1650" b="0">
+                <a:spcPct val="122000"/>
+              </a:lnSpc>
+              <a:buNone/>
+              <a:defRPr sz="1500" b="0">
+                <a:solidFill>
+                  <a:srgbClr val="555555"/>
+                </a:solidFill>
+                <a:latin typeface="Malgun Gothic"/>
+                <a:ea typeface="Malgun Gothic"/>
+                <a:cs typeface="Malgun Gothic"/>
+              </a:defRPr>
+            </a:pPr>
+            <a:r>
+              <a:rPr sz="1500" b="0">
                 <a:solidFill>
                   <a:srgbClr val="555555"/>
                 </a:solidFill>
@@ -3859,7 +3859,7 @@
           <p:cNvPr id="4" name="">
             <a:extLst xmlns:a="http://schemas.openxmlformats.org/drawingml/2006/main">
               <a:ext uri="{FF2B5EF4-FFF2-40B4-BE49-F238E27FC236}">
-                <a16:creationId xmlns:a16="http://schemas.microsoft.com/office/drawing/2014/main" id="{33FBAF8F-A116-40A8-9BB6-775C68D97988}"/>
+                <a16:creationId xmlns:a16="http://schemas.microsoft.com/office/drawing/2014/main" id="{CA7A4BF0-3F18-4891-AD56-9CB7D1D8F672}"/>
               </a:ext>
             </a:extLst>
           </p:cNvPr>
@@ -3919,7 +3919,7 @@
           <p:cNvPr id="5" name="">
             <a:extLst xmlns:a="http://schemas.openxmlformats.org/drawingml/2006/main">
               <a:ext uri="{FF2B5EF4-FFF2-40B4-BE49-F238E27FC236}">
-                <a16:creationId xmlns:a16="http://schemas.microsoft.com/office/drawing/2014/main" id="{7053363E-CB3A-4FD5-8FD3-C5278A11B2AC}"/>
+                <a16:creationId xmlns:a16="http://schemas.microsoft.com/office/drawing/2014/main" id="{8CCD8C17-E4FB-48D7-A750-590CEB825632}"/>
               </a:ext>
             </a:extLst>
           </p:cNvPr>
@@ -3979,7 +3979,7 @@
           <p:cNvPr id="6" name="">
             <a:extLst xmlns:a="http://schemas.openxmlformats.org/drawingml/2006/main">
               <a:ext uri="{FF2B5EF4-FFF2-40B4-BE49-F238E27FC236}">
-                <a16:creationId xmlns:a16="http://schemas.microsoft.com/office/drawing/2014/main" id="{EF995284-CBDB-4C47-80F0-653735968BC5}"/>
+                <a16:creationId xmlns:a16="http://schemas.microsoft.com/office/drawing/2014/main" id="{7FB74187-0A5C-4C96-B257-6A643F233819}"/>
               </a:ext>
             </a:extLst>
           </p:cNvPr>
@@ -4039,7 +4039,7 @@
           <p:cNvPr id="7" name="">
             <a:extLst xmlns:a="http://schemas.openxmlformats.org/drawingml/2006/main">
               <a:ext uri="{FF2B5EF4-FFF2-40B4-BE49-F238E27FC236}">
-                <a16:creationId xmlns:a16="http://schemas.microsoft.com/office/drawing/2014/main" id="{E9E4C284-8B72-460B-87AB-507792114FF2}"/>
+                <a16:creationId xmlns:a16="http://schemas.microsoft.com/office/drawing/2014/main" id="{26332404-2273-408C-841E-FDA3826EC525}"/>
               </a:ext>
             </a:extLst>
           </p:cNvPr>
@@ -4099,7 +4099,7 @@
           <p:cNvPr id="8" name="">
             <a:extLst xmlns:a="http://schemas.openxmlformats.org/drawingml/2006/main">
               <a:ext uri="{FF2B5EF4-FFF2-40B4-BE49-F238E27FC236}">
-                <a16:creationId xmlns:a16="http://schemas.microsoft.com/office/drawing/2014/main" id="{0123339A-40DA-486E-8613-F5BFBFCA3BD2}"/>
+                <a16:creationId xmlns:a16="http://schemas.microsoft.com/office/drawing/2014/main" id="{78D45F58-76B9-4F40-A85A-F6380ED23BA6}"/>
               </a:ext>
             </a:extLst>
           </p:cNvPr>
@@ -4159,7 +4159,7 @@
           <p:cNvPr id="9" name="">
             <a:extLst xmlns:a="http://schemas.openxmlformats.org/drawingml/2006/main">
               <a:ext uri="{FF2B5EF4-FFF2-40B4-BE49-F238E27FC236}">
-                <a16:creationId xmlns:a16="http://schemas.microsoft.com/office/drawing/2014/main" id="{971F89EA-036A-4E01-A528-3B8CBF9FBA8F}"/>
+                <a16:creationId xmlns:a16="http://schemas.microsoft.com/office/drawing/2014/main" id="{6A4E8F42-D26B-4FE4-BBF3-EEDF9D7EC6AD}"/>
               </a:ext>
             </a:extLst>
           </p:cNvPr>
@@ -4219,7 +4219,7 @@
           <p:cNvPr id="10" name="">
             <a:extLst xmlns:a="http://schemas.openxmlformats.org/drawingml/2006/main">
               <a:ext uri="{FF2B5EF4-FFF2-40B4-BE49-F238E27FC236}">
-                <a16:creationId xmlns:a16="http://schemas.microsoft.com/office/drawing/2014/main" id="{F1D1AA35-1CD6-4FD8-AAAA-11BCB5B985CD}"/>
+                <a16:creationId xmlns:a16="http://schemas.microsoft.com/office/drawing/2014/main" id="{64A71F1D-675D-4D87-9261-4F21950EBFCD}"/>
               </a:ext>
             </a:extLst>
           </p:cNvPr>
@@ -4279,7 +4279,7 @@
           <p:cNvPr id="11" name="">
             <a:extLst xmlns:a="http://schemas.openxmlformats.org/drawingml/2006/main">
               <a:ext uri="{FF2B5EF4-FFF2-40B4-BE49-F238E27FC236}">
-                <a16:creationId xmlns:a16="http://schemas.microsoft.com/office/drawing/2014/main" id="{A71BDACB-4D91-4241-B3F0-2297790BF6FE}"/>
+                <a16:creationId xmlns:a16="http://schemas.microsoft.com/office/drawing/2014/main" id="{52B3BD06-B8B2-432C-A86A-8B8E02920F1A}"/>
               </a:ext>
             </a:extLst>
           </p:cNvPr>
@@ -4291,7 +4291,7 @@
         <p:spPr>
           <a:xfrm xmlns:a="http://schemas.openxmlformats.org/drawingml/2006/main">
             <a:off x="6762750" y="2914650"/>
-            <a:ext cx="4476750" cy="2381250"/>
+            <a:ext cx="4476750" cy="2686050"/>
           </a:xfrm>
           <a:prstGeom xmlns:a="http://schemas.openxmlformats.org/drawingml/2006/main" prst="rect">
             <a:avLst/>
@@ -4310,7 +4310,7 @@
           <p:cNvPr id="12" name="">
             <a:extLst xmlns:a="http://schemas.openxmlformats.org/drawingml/2006/main">
               <a:ext uri="{FF2B5EF4-FFF2-40B4-BE49-F238E27FC236}">
-                <a16:creationId xmlns:a16="http://schemas.microsoft.com/office/drawing/2014/main" id="{6C06283F-1F70-4A11-9BC8-A3F89A8CE02A}"/>
+                <a16:creationId xmlns:a16="http://schemas.microsoft.com/office/drawing/2014/main" id="{01C87E9E-A81A-4315-9102-BD002DE519DB}"/>
               </a:ext>
             </a:extLst>
           </p:cNvPr>
@@ -4370,19 +4370,19 @@
           <p:cNvPr id="13" name="">
             <a:extLst xmlns:a="http://schemas.openxmlformats.org/drawingml/2006/main">
               <a:ext uri="{FF2B5EF4-FFF2-40B4-BE49-F238E27FC236}">
-                <a16:creationId xmlns:a16="http://schemas.microsoft.com/office/drawing/2014/main" id="{2C1DD4BA-D10E-424C-91B0-6BCC34D5E3A6}"/>
-              </a:ext>
-            </a:extLst>
-          </p:cNvPr>
-          <p:cNvSpPr>
-            <a:spLocks xmlns:a="http://schemas.openxmlformats.org/drawingml/2006/main" noGrp="1"/>
-          </p:cNvSpPr>
-          <p:nvPr/>
-        </p:nvSpPr>
-        <p:spPr>
-          <a:xfrm xmlns:a="http://schemas.openxmlformats.org/drawingml/2006/main">
-            <a:off x="7067550" y="3676650"/>
-            <a:ext cx="3619500" cy="1200150"/>
+                <a16:creationId xmlns:a16="http://schemas.microsoft.com/office/drawing/2014/main" id="{370BFAB2-33B2-476F-9AC6-A250CB11FA82}"/>
+              </a:ext>
+            </a:extLst>
+          </p:cNvPr>
+          <p:cNvSpPr>
+            <a:spLocks xmlns:a="http://schemas.openxmlformats.org/drawingml/2006/main" noGrp="1"/>
+          </p:cNvSpPr>
+          <p:nvPr/>
+        </p:nvSpPr>
+        <p:spPr>
+          <a:xfrm xmlns:a="http://schemas.openxmlformats.org/drawingml/2006/main">
+            <a:off x="7067550" y="3733800"/>
+            <a:ext cx="3695700" cy="1009650"/>
           </a:xfrm>
           <a:prstGeom xmlns:a="http://schemas.openxmlformats.org/drawingml/2006/main" prst="rect">
             <a:avLst/>
@@ -4402,7 +4402,7 @@
                 <a:spcPct val="120000"/>
               </a:lnSpc>
               <a:buNone/>
-              <a:defRPr sz="1500" b="0">
+              <a:defRPr sz="1350" b="0">
                 <a:solidFill>
                   <a:srgbClr val="000000"/>
                 </a:solidFill>
@@ -4412,7 +4412,7 @@
               </a:defRPr>
             </a:pPr>
             <a:r>
-              <a:rPr sz="1500" b="0">
+              <a:rPr sz="1350" b="0">
                 <a:solidFill>
                   <a:srgbClr val="000000"/>
                 </a:solidFill>
@@ -4429,7 +4429,7 @@
                 <a:spcPct val="120000"/>
               </a:lnSpc>
               <a:buNone/>
-              <a:defRPr sz="1500" b="0">
+              <a:defRPr sz="1350" b="0">
                 <a:solidFill>
                   <a:srgbClr val="000000"/>
                 </a:solidFill>
@@ -4439,7 +4439,7 @@
               </a:defRPr>
             </a:pPr>
             <a:r>
-              <a:rPr sz="1500" b="0">
+              <a:rPr sz="1350" b="0">
                 <a:solidFill>
                   <a:srgbClr val="000000"/>
                 </a:solidFill>
@@ -4456,7 +4456,7 @@
                 <a:spcPct val="120000"/>
               </a:lnSpc>
               <a:buNone/>
-              <a:defRPr sz="1500" b="0">
+              <a:defRPr sz="1350" b="0">
                 <a:solidFill>
                   <a:srgbClr val="000000"/>
                 </a:solidFill>
@@ -4466,7 +4466,7 @@
               </a:defRPr>
             </a:pPr>
             <a:r>
-              <a:rPr sz="1500" b="0">
+              <a:rPr sz="1350" b="0">
                 <a:solidFill>
                   <a:srgbClr val="000000"/>
                 </a:solidFill>
@@ -4484,19 +4484,19 @@
           <p:cNvPr id="14" name="">
             <a:extLst xmlns:a="http://schemas.openxmlformats.org/drawingml/2006/main">
               <a:ext uri="{FF2B5EF4-FFF2-40B4-BE49-F238E27FC236}">
-                <a16:creationId xmlns:a16="http://schemas.microsoft.com/office/drawing/2014/main" id="{B0995840-171D-4BAB-8B57-555551FCB083}"/>
-              </a:ext>
-            </a:extLst>
-          </p:cNvPr>
-          <p:cNvSpPr>
-            <a:spLocks xmlns:a="http://schemas.openxmlformats.org/drawingml/2006/main" noGrp="1"/>
-          </p:cNvSpPr>
-          <p:nvPr/>
-        </p:nvSpPr>
-        <p:spPr>
-          <a:xfrm xmlns:a="http://schemas.openxmlformats.org/drawingml/2006/main">
-            <a:off x="7067550" y="5010150"/>
-            <a:ext cx="3524250" cy="266700"/>
+                <a16:creationId xmlns:a16="http://schemas.microsoft.com/office/drawing/2014/main" id="{F90F07AC-B83A-44D2-9FF3-8AB6D8C9F99E}"/>
+              </a:ext>
+            </a:extLst>
+          </p:cNvPr>
+          <p:cNvSpPr>
+            <a:spLocks xmlns:a="http://schemas.openxmlformats.org/drawingml/2006/main" noGrp="1"/>
+          </p:cNvSpPr>
+          <p:nvPr/>
+        </p:nvSpPr>
+        <p:spPr>
+          <a:xfrm xmlns:a="http://schemas.openxmlformats.org/drawingml/2006/main">
+            <a:off x="7067550" y="5105400"/>
+            <a:ext cx="3695700" cy="381000"/>
           </a:xfrm>
           <a:prstGeom xmlns:a="http://schemas.openxmlformats.org/drawingml/2006/main" prst="rect">
             <a:avLst/>
@@ -4516,7 +4516,7 @@
                 <a:spcPct val="112000"/>
               </a:lnSpc>
               <a:buNone/>
-              <a:defRPr sz="1350" b="1">
+              <a:defRPr sz="1275" b="1">
                 <a:solidFill>
                   <a:srgbClr val="FF6B35"/>
                 </a:solidFill>
@@ -4526,7 +4526,7 @@
               </a:defRPr>
             </a:pPr>
             <a:r>
-              <a:rPr sz="1350" b="1">
+              <a:rPr sz="1275" b="1">
                 <a:solidFill>
                   <a:srgbClr val="FF6B35"/>
                 </a:solidFill>
@@ -4544,7 +4544,7 @@
           <p:cNvPr id="15" name="">
             <a:extLst xmlns:a="http://schemas.openxmlformats.org/drawingml/2006/main">
               <a:ext uri="{FF2B5EF4-FFF2-40B4-BE49-F238E27FC236}">
-                <a16:creationId xmlns:a16="http://schemas.microsoft.com/office/drawing/2014/main" id="{8405EF42-16B4-4F93-9C0D-E7CA6F455D03}"/>
+                <a16:creationId xmlns:a16="http://schemas.microsoft.com/office/drawing/2014/main" id="{AC192349-7C2E-4D8B-A7BC-6A2388A347EB}"/>
               </a:ext>
             </a:extLst>
           </p:cNvPr>
@@ -4575,7 +4575,7 @@
           <p:cNvPr id="16" name="">
             <a:extLst xmlns:a="http://schemas.openxmlformats.org/drawingml/2006/main">
               <a:ext uri="{FF2B5EF4-FFF2-40B4-BE49-F238E27FC236}">
-                <a16:creationId xmlns:a16="http://schemas.microsoft.com/office/drawing/2014/main" id="{2E1274C0-F105-44CA-9682-9CCE4B7C6149}"/>
+                <a16:creationId xmlns:a16="http://schemas.microsoft.com/office/drawing/2014/main" id="{D709E206-8EC3-405A-8393-E8488E793792}"/>
               </a:ext>
             </a:extLst>
           </p:cNvPr>
@@ -4635,7 +4635,7 @@
           <p:cNvPr id="17" name="">
             <a:extLst xmlns:a="http://schemas.openxmlformats.org/drawingml/2006/main">
               <a:ext uri="{FF2B5EF4-FFF2-40B4-BE49-F238E27FC236}">
-                <a16:creationId xmlns:a16="http://schemas.microsoft.com/office/drawing/2014/main" id="{30BB5667-38FF-4C65-8295-F9FEDD13DBFB}"/>
+                <a16:creationId xmlns:a16="http://schemas.microsoft.com/office/drawing/2014/main" id="{76CB2225-287A-4C44-A7DC-A552F7DC945C}"/>
               </a:ext>
             </a:extLst>
           </p:cNvPr>
@@ -4693,7 +4693,7 @@
     </p:spTree>
     <p:extLst>
       <p:ext uri="{BB962C8B-B14F-4D97-AF65-F5344CB8AC3E}">
-        <p14:creationId xmlns:p14="http://schemas.microsoft.com/office/powerpoint/2010/main" val="588528828"/>
+        <p14:creationId xmlns:p14="http://schemas.microsoft.com/office/powerpoint/2010/main" val="79208298"/>
       </p:ext>
     </p:extLst>
   </p:cSld>
@@ -4724,7 +4724,7 @@
           <p:cNvPr id="1" name="">
             <a:extLst xmlns:a="http://schemas.openxmlformats.org/drawingml/2006/main">
               <a:ext uri="{FF2B5EF4-FFF2-40B4-BE49-F238E27FC236}">
-                <a16:creationId xmlns:a16="http://schemas.microsoft.com/office/drawing/2014/main" id="{B8D153D6-53AE-4F0A-BAD1-C0A8E5775CBE}"/>
+                <a16:creationId xmlns:a16="http://schemas.microsoft.com/office/drawing/2014/main" id="{E4D010AF-5EAB-4B4D-A14E-0EB9AED85D35}"/>
               </a:ext>
             </a:extLst>
           </p:cNvPr>
@@ -4784,7 +4784,7 @@
           <p:cNvPr id="2" name="">
             <a:extLst xmlns:a="http://schemas.openxmlformats.org/drawingml/2006/main">
               <a:ext uri="{FF2B5EF4-FFF2-40B4-BE49-F238E27FC236}">
-                <a16:creationId xmlns:a16="http://schemas.microsoft.com/office/drawing/2014/main" id="{AC8E8636-383D-4729-BD6B-9D91F9CBD8D9}"/>
+                <a16:creationId xmlns:a16="http://schemas.microsoft.com/office/drawing/2014/main" id="{0CF0C14A-4068-4118-B4BD-2673F776044A}"/>
               </a:ext>
             </a:extLst>
           </p:cNvPr>
@@ -4796,7 +4796,7 @@
         <p:spPr>
           <a:xfrm xmlns:a="http://schemas.openxmlformats.org/drawingml/2006/main">
             <a:off x="400050" y="742950"/>
-            <a:ext cx="8858250" cy="1123950"/>
+            <a:ext cx="8572500" cy="1238250"/>
           </a:xfrm>
           <a:prstGeom xmlns:a="http://schemas.openxmlformats.org/drawingml/2006/main" prst="rect">
             <a:avLst/>
@@ -4813,10 +4813,10 @@
           <a:p xmlns:a="http://schemas.openxmlformats.org/drawingml/2006/main">
             <a:pPr algn="l">
               <a:lnSpc>
-                <a:spcPct val="102000"/>
-              </a:lnSpc>
-              <a:buNone/>
-              <a:defRPr sz="3600" b="1">
+                <a:spcPct val="105000"/>
+              </a:lnSpc>
+              <a:buNone/>
+              <a:defRPr sz="3150" b="1">
                 <a:solidFill>
                   <a:srgbClr val="000000"/>
                 </a:solidFill>
@@ -4826,7 +4826,7 @@
               </a:defRPr>
             </a:pPr>
             <a:r>
-              <a:rPr sz="3600" b="1">
+              <a:rPr sz="3150" b="1">
                 <a:solidFill>
                   <a:srgbClr val="000000"/>
                 </a:solidFill>
@@ -4844,19 +4844,19 @@
           <p:cNvPr id="3" name="">
             <a:extLst xmlns:a="http://schemas.openxmlformats.org/drawingml/2006/main">
               <a:ext uri="{FF2B5EF4-FFF2-40B4-BE49-F238E27FC236}">
-                <a16:creationId xmlns:a16="http://schemas.microsoft.com/office/drawing/2014/main" id="{F7EC400B-DD3C-4817-8CCE-FEB59069CCFC}"/>
-              </a:ext>
-            </a:extLst>
-          </p:cNvPr>
-          <p:cNvSpPr>
-            <a:spLocks xmlns:a="http://schemas.openxmlformats.org/drawingml/2006/main" noGrp="1"/>
-          </p:cNvSpPr>
-          <p:nvPr/>
-        </p:nvSpPr>
-        <p:spPr>
-          <a:xfrm xmlns:a="http://schemas.openxmlformats.org/drawingml/2006/main">
-            <a:off x="400050" y="1943100"/>
-            <a:ext cx="7239000" cy="609600"/>
+                <a16:creationId xmlns:a16="http://schemas.microsoft.com/office/drawing/2014/main" id="{9569CFD1-5A52-45F0-AC1F-6136C8AD8083}"/>
+              </a:ext>
+            </a:extLst>
+          </p:cNvPr>
+          <p:cNvSpPr>
+            <a:spLocks xmlns:a="http://schemas.openxmlformats.org/drawingml/2006/main" noGrp="1"/>
+          </p:cNvSpPr>
+          <p:nvPr/>
+        </p:nvSpPr>
+        <p:spPr>
+          <a:xfrm xmlns:a="http://schemas.openxmlformats.org/drawingml/2006/main">
+            <a:off x="400050" y="2076450"/>
+            <a:ext cx="7620000" cy="590550"/>
           </a:xfrm>
           <a:prstGeom xmlns:a="http://schemas.openxmlformats.org/drawingml/2006/main" prst="rect">
             <a:avLst/>
@@ -4873,20 +4873,20 @@
           <a:p xmlns:a="http://schemas.openxmlformats.org/drawingml/2006/main">
             <a:pPr algn="l">
               <a:lnSpc>
-                <a:spcPct val="125000"/>
-              </a:lnSpc>
-              <a:buNone/>
-              <a:defRPr sz="1650" b="0">
-                <a:solidFill>
-                  <a:srgbClr val="555555"/>
-                </a:solidFill>
-                <a:latin typeface="Malgun Gothic"/>
-                <a:ea typeface="Malgun Gothic"/>
-                <a:cs typeface="Malgun Gothic"/>
-              </a:defRPr>
-            </a:pPr>
-            <a:r>
-              <a:rPr sz="1650" b="0">
+                <a:spcPct val="122000"/>
+              </a:lnSpc>
+              <a:buNone/>
+              <a:defRPr sz="1500" b="0">
+                <a:solidFill>
+                  <a:srgbClr val="555555"/>
+                </a:solidFill>
+                <a:latin typeface="Malgun Gothic"/>
+                <a:ea typeface="Malgun Gothic"/>
+                <a:cs typeface="Malgun Gothic"/>
+              </a:defRPr>
+            </a:pPr>
+            <a:r>
+              <a:rPr sz="1500" b="0">
                 <a:solidFill>
                   <a:srgbClr val="555555"/>
                 </a:solidFill>
@@ -4904,7 +4904,7 @@
           <p:cNvPr id="4" name="">
             <a:extLst xmlns:a="http://schemas.openxmlformats.org/drawingml/2006/main">
               <a:ext uri="{FF2B5EF4-FFF2-40B4-BE49-F238E27FC236}">
-                <a16:creationId xmlns:a16="http://schemas.microsoft.com/office/drawing/2014/main" id="{66F65708-2545-4F44-A5CE-457E007D1179}"/>
+                <a16:creationId xmlns:a16="http://schemas.microsoft.com/office/drawing/2014/main" id="{8BEB0603-64CF-478C-84E2-D7A023D7CFA3}"/>
               </a:ext>
             </a:extLst>
           </p:cNvPr>
@@ -4964,7 +4964,7 @@
           <p:cNvPr id="5" name="">
             <a:extLst xmlns:a="http://schemas.openxmlformats.org/drawingml/2006/main">
               <a:ext uri="{FF2B5EF4-FFF2-40B4-BE49-F238E27FC236}">
-                <a16:creationId xmlns:a16="http://schemas.microsoft.com/office/drawing/2014/main" id="{752C9266-2ED8-4305-BF3D-2B4D0CA2F4A7}"/>
+                <a16:creationId xmlns:a16="http://schemas.microsoft.com/office/drawing/2014/main" id="{9D648D72-69FD-41DE-9747-41293EFA051F}"/>
               </a:ext>
             </a:extLst>
           </p:cNvPr>
@@ -4995,7 +4995,7 @@
           <p:cNvPr id="6" name="">
             <a:extLst xmlns:a="http://schemas.openxmlformats.org/drawingml/2006/main">
               <a:ext uri="{FF2B5EF4-FFF2-40B4-BE49-F238E27FC236}">
-                <a16:creationId xmlns:a16="http://schemas.microsoft.com/office/drawing/2014/main" id="{DDA669B8-B5A9-4EDA-8DA2-440A36347E16}"/>
+                <a16:creationId xmlns:a16="http://schemas.microsoft.com/office/drawing/2014/main" id="{A600246D-6C71-4AD8-9136-99BC5F70845D}"/>
               </a:ext>
             </a:extLst>
           </p:cNvPr>
@@ -5055,7 +5055,7 @@
           <p:cNvPr id="7" name="">
             <a:extLst xmlns:a="http://schemas.openxmlformats.org/drawingml/2006/main">
               <a:ext uri="{FF2B5EF4-FFF2-40B4-BE49-F238E27FC236}">
-                <a16:creationId xmlns:a16="http://schemas.microsoft.com/office/drawing/2014/main" id="{9ACC48BD-A324-4F69-8E6B-9D0ED74FFD7F}"/>
+                <a16:creationId xmlns:a16="http://schemas.microsoft.com/office/drawing/2014/main" id="{5EB9330B-C89F-41B8-97FD-1266B2039434}"/>
               </a:ext>
             </a:extLst>
           </p:cNvPr>
@@ -5115,7 +5115,7 @@
           <p:cNvPr id="8" name="">
             <a:extLst xmlns:a="http://schemas.openxmlformats.org/drawingml/2006/main">
               <a:ext uri="{FF2B5EF4-FFF2-40B4-BE49-F238E27FC236}">
-                <a16:creationId xmlns:a16="http://schemas.microsoft.com/office/drawing/2014/main" id="{74B2ECB2-FFF6-4FA8-9307-D425098A7681}"/>
+                <a16:creationId xmlns:a16="http://schemas.microsoft.com/office/drawing/2014/main" id="{975981EE-8E77-4953-B65F-464943382DC1}"/>
               </a:ext>
             </a:extLst>
           </p:cNvPr>
@@ -5175,7 +5175,7 @@
           <p:cNvPr id="9" name="">
             <a:extLst xmlns:a="http://schemas.openxmlformats.org/drawingml/2006/main">
               <a:ext uri="{FF2B5EF4-FFF2-40B4-BE49-F238E27FC236}">
-                <a16:creationId xmlns:a16="http://schemas.microsoft.com/office/drawing/2014/main" id="{C3963233-E2DF-40C6-AE9F-A30B4F5094C7}"/>
+                <a16:creationId xmlns:a16="http://schemas.microsoft.com/office/drawing/2014/main" id="{10DD10B1-612A-4926-9F26-BE4AB4F64365}"/>
               </a:ext>
             </a:extLst>
           </p:cNvPr>
@@ -5235,7 +5235,7 @@
           <p:cNvPr id="10" name="">
             <a:extLst xmlns:a="http://schemas.openxmlformats.org/drawingml/2006/main">
               <a:ext uri="{FF2B5EF4-FFF2-40B4-BE49-F238E27FC236}">
-                <a16:creationId xmlns:a16="http://schemas.microsoft.com/office/drawing/2014/main" id="{8A1DE4C8-AB87-47C8-9F8E-9194D9BD2B93}"/>
+                <a16:creationId xmlns:a16="http://schemas.microsoft.com/office/drawing/2014/main" id="{112E97CB-7E91-46D7-8937-AEF8719337DF}"/>
               </a:ext>
             </a:extLst>
           </p:cNvPr>
@@ -5295,7 +5295,7 @@
           <p:cNvPr id="11" name="">
             <a:extLst xmlns:a="http://schemas.openxmlformats.org/drawingml/2006/main">
               <a:ext uri="{FF2B5EF4-FFF2-40B4-BE49-F238E27FC236}">
-                <a16:creationId xmlns:a16="http://schemas.microsoft.com/office/drawing/2014/main" id="{B3928E08-F69F-4837-933F-967965597603}"/>
+                <a16:creationId xmlns:a16="http://schemas.microsoft.com/office/drawing/2014/main" id="{B89ECF5C-5042-4F4C-9192-E89C52D66510}"/>
               </a:ext>
             </a:extLst>
           </p:cNvPr>
@@ -5355,7 +5355,7 @@
           <p:cNvPr id="12" name="">
             <a:extLst xmlns:a="http://schemas.openxmlformats.org/drawingml/2006/main">
               <a:ext uri="{FF2B5EF4-FFF2-40B4-BE49-F238E27FC236}">
-                <a16:creationId xmlns:a16="http://schemas.microsoft.com/office/drawing/2014/main" id="{DE566CA1-E30E-4A69-B814-4EB254EF8829}"/>
+                <a16:creationId xmlns:a16="http://schemas.microsoft.com/office/drawing/2014/main" id="{042E5AED-A701-4850-9021-386AFEBCD197}"/>
               </a:ext>
             </a:extLst>
           </p:cNvPr>
@@ -5415,7 +5415,7 @@
           <p:cNvPr id="13" name="">
             <a:extLst xmlns:a="http://schemas.openxmlformats.org/drawingml/2006/main">
               <a:ext uri="{FF2B5EF4-FFF2-40B4-BE49-F238E27FC236}">
-                <a16:creationId xmlns:a16="http://schemas.microsoft.com/office/drawing/2014/main" id="{073FC4B3-D5F6-4D8B-A5EA-9136B0921D0E}"/>
+                <a16:creationId xmlns:a16="http://schemas.microsoft.com/office/drawing/2014/main" id="{0C6C1BF1-DC20-478E-886C-F26D1D5A6DF1}"/>
               </a:ext>
             </a:extLst>
           </p:cNvPr>
@@ -5475,7 +5475,7 @@
           <p:cNvPr id="14" name="">
             <a:extLst xmlns:a="http://schemas.openxmlformats.org/drawingml/2006/main">
               <a:ext uri="{FF2B5EF4-FFF2-40B4-BE49-F238E27FC236}">
-                <a16:creationId xmlns:a16="http://schemas.microsoft.com/office/drawing/2014/main" id="{88226B22-4B25-4DC1-BABC-6D6DE22A1A44}"/>
+                <a16:creationId xmlns:a16="http://schemas.microsoft.com/office/drawing/2014/main" id="{2D111F46-74A8-4763-AD5C-05DEF78A4B5C}"/>
               </a:ext>
             </a:extLst>
           </p:cNvPr>
@@ -5535,7 +5535,7 @@
           <p:cNvPr id="15" name="">
             <a:extLst xmlns:a="http://schemas.openxmlformats.org/drawingml/2006/main">
               <a:ext uri="{FF2B5EF4-FFF2-40B4-BE49-F238E27FC236}">
-                <a16:creationId xmlns:a16="http://schemas.microsoft.com/office/drawing/2014/main" id="{ED252710-03D7-47A2-A544-81044D1F0C79}"/>
+                <a16:creationId xmlns:a16="http://schemas.microsoft.com/office/drawing/2014/main" id="{9F0BC85B-3521-47E9-8B99-B6D60F6C6E21}"/>
               </a:ext>
             </a:extLst>
           </p:cNvPr>
@@ -5547,7 +5547,7 @@
         <p:spPr>
           <a:xfrm xmlns:a="http://schemas.openxmlformats.org/drawingml/2006/main">
             <a:off x="876300" y="5619750"/>
-            <a:ext cx="9334500" cy="323850"/>
+            <a:ext cx="9334500" cy="419100"/>
           </a:xfrm>
           <a:prstGeom xmlns:a="http://schemas.openxmlformats.org/drawingml/2006/main" prst="rect">
             <a:avLst/>
@@ -5567,7 +5567,7 @@
                 <a:spcPct val="112000"/>
               </a:lnSpc>
               <a:buNone/>
-              <a:defRPr sz="1650" b="1">
+              <a:defRPr sz="1425" b="1">
                 <a:solidFill>
                   <a:srgbClr val="FF6B35"/>
                 </a:solidFill>
@@ -5577,7 +5577,7 @@
               </a:defRPr>
             </a:pPr>
             <a:r>
-              <a:rPr sz="1650" b="1">
+              <a:rPr sz="1425" b="1">
                 <a:solidFill>
                   <a:srgbClr val="FF6B35"/>
                 </a:solidFill>
@@ -5595,7 +5595,7 @@
           <p:cNvPr id="16" name="">
             <a:extLst xmlns:a="http://schemas.openxmlformats.org/drawingml/2006/main">
               <a:ext uri="{FF2B5EF4-FFF2-40B4-BE49-F238E27FC236}">
-                <a16:creationId xmlns:a16="http://schemas.microsoft.com/office/drawing/2014/main" id="{17D674A6-0C3F-4F9E-8E20-ACC8B6F3E9C7}"/>
+                <a16:creationId xmlns:a16="http://schemas.microsoft.com/office/drawing/2014/main" id="{D60B581E-6E5A-4D18-A78F-30B801668765}"/>
               </a:ext>
             </a:extLst>
           </p:cNvPr>
@@ -5626,7 +5626,7 @@
           <p:cNvPr id="17" name="">
             <a:extLst xmlns:a="http://schemas.openxmlformats.org/drawingml/2006/main">
               <a:ext uri="{FF2B5EF4-FFF2-40B4-BE49-F238E27FC236}">
-                <a16:creationId xmlns:a16="http://schemas.microsoft.com/office/drawing/2014/main" id="{65B670E0-3E68-428E-850B-9AAF9DB83A1C}"/>
+                <a16:creationId xmlns:a16="http://schemas.microsoft.com/office/drawing/2014/main" id="{F94B43DF-69D6-4399-867B-58E38891AD34}"/>
               </a:ext>
             </a:extLst>
           </p:cNvPr>
@@ -5686,7 +5686,7 @@
           <p:cNvPr id="18" name="">
             <a:extLst xmlns:a="http://schemas.openxmlformats.org/drawingml/2006/main">
               <a:ext uri="{FF2B5EF4-FFF2-40B4-BE49-F238E27FC236}">
-                <a16:creationId xmlns:a16="http://schemas.microsoft.com/office/drawing/2014/main" id="{469B9229-88B2-4917-A799-DADA7BE5916E}"/>
+                <a16:creationId xmlns:a16="http://schemas.microsoft.com/office/drawing/2014/main" id="{4269CF4D-A59D-436C-B281-0E77BEA4F7D5}"/>
               </a:ext>
             </a:extLst>
           </p:cNvPr>
@@ -5744,7 +5744,7 @@
     </p:spTree>
     <p:extLst>
       <p:ext uri="{BB962C8B-B14F-4D97-AF65-F5344CB8AC3E}">
-        <p14:creationId xmlns:p14="http://schemas.microsoft.com/office/powerpoint/2010/main" val="1079168961"/>
+        <p14:creationId xmlns:p14="http://schemas.microsoft.com/office/powerpoint/2010/main" val="601525397"/>
       </p:ext>
     </p:extLst>
   </p:cSld>
@@ -5775,7 +5775,7 @@
           <p:cNvPr id="1" name="">
             <a:extLst xmlns:a="http://schemas.openxmlformats.org/drawingml/2006/main">
               <a:ext uri="{FF2B5EF4-FFF2-40B4-BE49-F238E27FC236}">
-                <a16:creationId xmlns:a16="http://schemas.microsoft.com/office/drawing/2014/main" id="{54EE788F-1D44-4EA0-9307-51EE722B0EC6}"/>
+                <a16:creationId xmlns:a16="http://schemas.microsoft.com/office/drawing/2014/main" id="{4B0FBC00-4A46-4185-A95D-41EAC445E711}"/>
               </a:ext>
             </a:extLst>
           </p:cNvPr>
@@ -5835,7 +5835,7 @@
           <p:cNvPr id="2" name="">
             <a:extLst xmlns:a="http://schemas.openxmlformats.org/drawingml/2006/main">
               <a:ext uri="{FF2B5EF4-FFF2-40B4-BE49-F238E27FC236}">
-                <a16:creationId xmlns:a16="http://schemas.microsoft.com/office/drawing/2014/main" id="{DEB92F2A-D2E8-48FB-A14D-C4BB1E1EBEA5}"/>
+                <a16:creationId xmlns:a16="http://schemas.microsoft.com/office/drawing/2014/main" id="{63DEDD5A-BDB8-4273-91A5-5B70970A553C}"/>
               </a:ext>
             </a:extLst>
           </p:cNvPr>
@@ -5847,7 +5847,7 @@
         <p:spPr>
           <a:xfrm xmlns:a="http://schemas.openxmlformats.org/drawingml/2006/main">
             <a:off x="400050" y="742950"/>
-            <a:ext cx="8858250" cy="1123950"/>
+            <a:ext cx="8572500" cy="1238250"/>
           </a:xfrm>
           <a:prstGeom xmlns:a="http://schemas.openxmlformats.org/drawingml/2006/main" prst="rect">
             <a:avLst/>
@@ -5864,10 +5864,10 @@
           <a:p xmlns:a="http://schemas.openxmlformats.org/drawingml/2006/main">
             <a:pPr algn="l">
               <a:lnSpc>
-                <a:spcPct val="102000"/>
-              </a:lnSpc>
-              <a:buNone/>
-              <a:defRPr sz="3600" b="1">
+                <a:spcPct val="105000"/>
+              </a:lnSpc>
+              <a:buNone/>
+              <a:defRPr sz="3150" b="1">
                 <a:solidFill>
                   <a:srgbClr val="000000"/>
                 </a:solidFill>
@@ -5877,7 +5877,7 @@
               </a:defRPr>
             </a:pPr>
             <a:r>
-              <a:rPr sz="3600" b="1">
+              <a:rPr sz="3150" b="1">
                 <a:solidFill>
                   <a:srgbClr val="000000"/>
                 </a:solidFill>
@@ -5895,19 +5895,19 @@
           <p:cNvPr id="3" name="">
             <a:extLst xmlns:a="http://schemas.openxmlformats.org/drawingml/2006/main">
               <a:ext uri="{FF2B5EF4-FFF2-40B4-BE49-F238E27FC236}">
-                <a16:creationId xmlns:a16="http://schemas.microsoft.com/office/drawing/2014/main" id="{1F77639F-97E1-4C14-A8E0-0DE0FA6318B2}"/>
-              </a:ext>
-            </a:extLst>
-          </p:cNvPr>
-          <p:cNvSpPr>
-            <a:spLocks xmlns:a="http://schemas.openxmlformats.org/drawingml/2006/main" noGrp="1"/>
-          </p:cNvSpPr>
-          <p:nvPr/>
-        </p:nvSpPr>
-        <p:spPr>
-          <a:xfrm xmlns:a="http://schemas.openxmlformats.org/drawingml/2006/main">
-            <a:off x="400050" y="1943100"/>
-            <a:ext cx="7239000" cy="609600"/>
+                <a16:creationId xmlns:a16="http://schemas.microsoft.com/office/drawing/2014/main" id="{32130B35-4F13-43D6-847B-BAF4BEADC6FA}"/>
+              </a:ext>
+            </a:extLst>
+          </p:cNvPr>
+          <p:cNvSpPr>
+            <a:spLocks xmlns:a="http://schemas.openxmlformats.org/drawingml/2006/main" noGrp="1"/>
+          </p:cNvSpPr>
+          <p:nvPr/>
+        </p:nvSpPr>
+        <p:spPr>
+          <a:xfrm xmlns:a="http://schemas.openxmlformats.org/drawingml/2006/main">
+            <a:off x="400050" y="2076450"/>
+            <a:ext cx="7620000" cy="590550"/>
           </a:xfrm>
           <a:prstGeom xmlns:a="http://schemas.openxmlformats.org/drawingml/2006/main" prst="rect">
             <a:avLst/>
@@ -5924,20 +5924,20 @@
           <a:p xmlns:a="http://schemas.openxmlformats.org/drawingml/2006/main">
             <a:pPr algn="l">
               <a:lnSpc>
-                <a:spcPct val="125000"/>
-              </a:lnSpc>
-              <a:buNone/>
-              <a:defRPr sz="1650" b="0">
-                <a:solidFill>
-                  <a:srgbClr val="555555"/>
-                </a:solidFill>
-                <a:latin typeface="Malgun Gothic"/>
-                <a:ea typeface="Malgun Gothic"/>
-                <a:cs typeface="Malgun Gothic"/>
-              </a:defRPr>
-            </a:pPr>
-            <a:r>
-              <a:rPr sz="1650" b="0">
+                <a:spcPct val="122000"/>
+              </a:lnSpc>
+              <a:buNone/>
+              <a:defRPr sz="1500" b="0">
+                <a:solidFill>
+                  <a:srgbClr val="555555"/>
+                </a:solidFill>
+                <a:latin typeface="Malgun Gothic"/>
+                <a:ea typeface="Malgun Gothic"/>
+                <a:cs typeface="Malgun Gothic"/>
+              </a:defRPr>
+            </a:pPr>
+            <a:r>
+              <a:rPr sz="1500" b="0">
                 <a:solidFill>
                   <a:srgbClr val="555555"/>
                 </a:solidFill>
@@ -5955,7 +5955,7 @@
           <p:cNvPr id="4" name="">
             <a:extLst xmlns:a="http://schemas.openxmlformats.org/drawingml/2006/main">
               <a:ext uri="{FF2B5EF4-FFF2-40B4-BE49-F238E27FC236}">
-                <a16:creationId xmlns:a16="http://schemas.microsoft.com/office/drawing/2014/main" id="{63200BCB-CB01-4F82-9791-954724C9DD74}"/>
+                <a16:creationId xmlns:a16="http://schemas.microsoft.com/office/drawing/2014/main" id="{45E5C139-AEDC-47F3-B38F-8A9596FDEFD2}"/>
               </a:ext>
             </a:extLst>
           </p:cNvPr>
@@ -6015,7 +6015,7 @@
           <p:cNvPr id="5" name="">
             <a:extLst xmlns:a="http://schemas.openxmlformats.org/drawingml/2006/main">
               <a:ext uri="{FF2B5EF4-FFF2-40B4-BE49-F238E27FC236}">
-                <a16:creationId xmlns:a16="http://schemas.microsoft.com/office/drawing/2014/main" id="{350C97D5-D6A4-47A3-86F8-2C85FAD9267A}"/>
+                <a16:creationId xmlns:a16="http://schemas.microsoft.com/office/drawing/2014/main" id="{85B82D6B-EDFF-48F3-83BA-5115E620D742}"/>
               </a:ext>
             </a:extLst>
           </p:cNvPr>
@@ -6046,7 +6046,7 @@
           <p:cNvPr id="6" name="">
             <a:extLst xmlns:a="http://schemas.openxmlformats.org/drawingml/2006/main">
               <a:ext uri="{FF2B5EF4-FFF2-40B4-BE49-F238E27FC236}">
-                <a16:creationId xmlns:a16="http://schemas.microsoft.com/office/drawing/2014/main" id="{E181E06F-1C33-4CA0-957D-3C8996FD70F3}"/>
+                <a16:creationId xmlns:a16="http://schemas.microsoft.com/office/drawing/2014/main" id="{F01A89A1-32DD-4BAA-8674-DF174E5A5844}"/>
               </a:ext>
             </a:extLst>
           </p:cNvPr>
@@ -6077,7 +6077,7 @@
           <p:cNvPr id="7" name="">
             <a:extLst xmlns:a="http://schemas.openxmlformats.org/drawingml/2006/main">
               <a:ext uri="{FF2B5EF4-FFF2-40B4-BE49-F238E27FC236}">
-                <a16:creationId xmlns:a16="http://schemas.microsoft.com/office/drawing/2014/main" id="{76E89911-AB7A-4500-87B9-AB672C077D0A}"/>
+                <a16:creationId xmlns:a16="http://schemas.microsoft.com/office/drawing/2014/main" id="{E5D0B7E3-5DF3-4BB8-B28E-E921A74C607C}"/>
               </a:ext>
             </a:extLst>
           </p:cNvPr>
@@ -6137,7 +6137,7 @@
           <p:cNvPr id="8" name="">
             <a:extLst xmlns:a="http://schemas.openxmlformats.org/drawingml/2006/main">
               <a:ext uri="{FF2B5EF4-FFF2-40B4-BE49-F238E27FC236}">
-                <a16:creationId xmlns:a16="http://schemas.microsoft.com/office/drawing/2014/main" id="{B4C95744-D70F-44F4-8302-D54EC9C30D79}"/>
+                <a16:creationId xmlns:a16="http://schemas.microsoft.com/office/drawing/2014/main" id="{4656E6D3-7B4E-4B25-8954-9F2E2EAAF9D0}"/>
               </a:ext>
             </a:extLst>
           </p:cNvPr>
@@ -6197,7 +6197,7 @@
           <p:cNvPr id="9" name="">
             <a:extLst xmlns:a="http://schemas.openxmlformats.org/drawingml/2006/main">
               <a:ext uri="{FF2B5EF4-FFF2-40B4-BE49-F238E27FC236}">
-                <a16:creationId xmlns:a16="http://schemas.microsoft.com/office/drawing/2014/main" id="{A6EC0B0D-5744-42C2-869F-491ACA8988C9}"/>
+                <a16:creationId xmlns:a16="http://schemas.microsoft.com/office/drawing/2014/main" id="{41FDD025-D38E-4F46-9B31-EEBB96BA76A5}"/>
               </a:ext>
             </a:extLst>
           </p:cNvPr>
@@ -6257,7 +6257,7 @@
           <p:cNvPr id="10" name="">
             <a:extLst xmlns:a="http://schemas.openxmlformats.org/drawingml/2006/main">
               <a:ext uri="{FF2B5EF4-FFF2-40B4-BE49-F238E27FC236}">
-                <a16:creationId xmlns:a16="http://schemas.microsoft.com/office/drawing/2014/main" id="{4BB076A2-51E6-4434-A98B-16217C8C01EB}"/>
+                <a16:creationId xmlns:a16="http://schemas.microsoft.com/office/drawing/2014/main" id="{3D270231-909C-4968-9B46-928CB6BA60F4}"/>
               </a:ext>
             </a:extLst>
           </p:cNvPr>
@@ -6317,7 +6317,7 @@
           <p:cNvPr id="11" name="">
             <a:extLst xmlns:a="http://schemas.openxmlformats.org/drawingml/2006/main">
               <a:ext uri="{FF2B5EF4-FFF2-40B4-BE49-F238E27FC236}">
-                <a16:creationId xmlns:a16="http://schemas.microsoft.com/office/drawing/2014/main" id="{09E60048-D265-43EF-AAB5-404F2637F871}"/>
+                <a16:creationId xmlns:a16="http://schemas.microsoft.com/office/drawing/2014/main" id="{CE418DB9-CCCC-459E-B5B1-7F8A8F15BFF1}"/>
               </a:ext>
             </a:extLst>
           </p:cNvPr>
@@ -6377,7 +6377,7 @@
           <p:cNvPr id="12" name="">
             <a:extLst xmlns:a="http://schemas.openxmlformats.org/drawingml/2006/main">
               <a:ext uri="{FF2B5EF4-FFF2-40B4-BE49-F238E27FC236}">
-                <a16:creationId xmlns:a16="http://schemas.microsoft.com/office/drawing/2014/main" id="{40707EE5-B252-49C9-A0BC-1E60E3AB3D47}"/>
+                <a16:creationId xmlns:a16="http://schemas.microsoft.com/office/drawing/2014/main" id="{0512C617-7872-40DA-B78D-3DDBC6E5F07A}"/>
               </a:ext>
             </a:extLst>
           </p:cNvPr>
@@ -6437,7 +6437,7 @@
           <p:cNvPr id="13" name="">
             <a:extLst xmlns:a="http://schemas.openxmlformats.org/drawingml/2006/main">
               <a:ext uri="{FF2B5EF4-FFF2-40B4-BE49-F238E27FC236}">
-                <a16:creationId xmlns:a16="http://schemas.microsoft.com/office/drawing/2014/main" id="{176AC889-E72C-40CF-8BBB-3496A1126816}"/>
+                <a16:creationId xmlns:a16="http://schemas.microsoft.com/office/drawing/2014/main" id="{B647789F-ECA9-4DD4-BC5E-589060102E75}"/>
               </a:ext>
             </a:extLst>
           </p:cNvPr>
@@ -6497,7 +6497,7 @@
           <p:cNvPr id="14" name="">
             <a:extLst xmlns:a="http://schemas.openxmlformats.org/drawingml/2006/main">
               <a:ext uri="{FF2B5EF4-FFF2-40B4-BE49-F238E27FC236}">
-                <a16:creationId xmlns:a16="http://schemas.microsoft.com/office/drawing/2014/main" id="{2FC5B98B-6CB0-4AFF-AB97-668C92A0E775}"/>
+                <a16:creationId xmlns:a16="http://schemas.microsoft.com/office/drawing/2014/main" id="{5148D122-462A-4672-8B58-7DEBC4507F60}"/>
               </a:ext>
             </a:extLst>
           </p:cNvPr>
@@ -6557,7 +6557,7 @@
           <p:cNvPr id="15" name="">
             <a:extLst xmlns:a="http://schemas.openxmlformats.org/drawingml/2006/main">
               <a:ext uri="{FF2B5EF4-FFF2-40B4-BE49-F238E27FC236}">
-                <a16:creationId xmlns:a16="http://schemas.microsoft.com/office/drawing/2014/main" id="{26B44AA9-E284-4E0E-96F9-C8D53DE7F322}"/>
+                <a16:creationId xmlns:a16="http://schemas.microsoft.com/office/drawing/2014/main" id="{4C1A3DCC-8E54-42B3-93BC-891F0F4CD2B7}"/>
               </a:ext>
             </a:extLst>
           </p:cNvPr>
@@ -6617,7 +6617,7 @@
           <p:cNvPr id="16" name="">
             <a:extLst xmlns:a="http://schemas.openxmlformats.org/drawingml/2006/main">
               <a:ext uri="{FF2B5EF4-FFF2-40B4-BE49-F238E27FC236}">
-                <a16:creationId xmlns:a16="http://schemas.microsoft.com/office/drawing/2014/main" id="{5D71FCE8-A2D2-4C68-A432-BE6DF7A42576}"/>
+                <a16:creationId xmlns:a16="http://schemas.microsoft.com/office/drawing/2014/main" id="{693F09A8-8404-43E4-BDB6-A3F70E6D8965}"/>
               </a:ext>
             </a:extLst>
           </p:cNvPr>
@@ -6677,7 +6677,7 @@
           <p:cNvPr id="17" name="">
             <a:extLst xmlns:a="http://schemas.openxmlformats.org/drawingml/2006/main">
               <a:ext uri="{FF2B5EF4-FFF2-40B4-BE49-F238E27FC236}">
-                <a16:creationId xmlns:a16="http://schemas.microsoft.com/office/drawing/2014/main" id="{017A06FA-E43A-4739-B4C3-A83F3C3E668C}"/>
+                <a16:creationId xmlns:a16="http://schemas.microsoft.com/office/drawing/2014/main" id="{6E671FE1-2975-48F3-85A3-98464184DBD6}"/>
               </a:ext>
             </a:extLst>
           </p:cNvPr>
@@ -6737,7 +6737,7 @@
           <p:cNvPr id="18" name="">
             <a:extLst xmlns:a="http://schemas.openxmlformats.org/drawingml/2006/main">
               <a:ext uri="{FF2B5EF4-FFF2-40B4-BE49-F238E27FC236}">
-                <a16:creationId xmlns:a16="http://schemas.microsoft.com/office/drawing/2014/main" id="{7CBF6FFA-1935-4769-881D-0FC97D0271AB}"/>
+                <a16:creationId xmlns:a16="http://schemas.microsoft.com/office/drawing/2014/main" id="{32E4F758-62B0-40E1-A318-2BB878C783A4}"/>
               </a:ext>
             </a:extLst>
           </p:cNvPr>
@@ -6768,7 +6768,7 @@
           <p:cNvPr id="19" name="">
             <a:extLst xmlns:a="http://schemas.openxmlformats.org/drawingml/2006/main">
               <a:ext uri="{FF2B5EF4-FFF2-40B4-BE49-F238E27FC236}">
-                <a16:creationId xmlns:a16="http://schemas.microsoft.com/office/drawing/2014/main" id="{CDD3E646-B4D2-4794-BAA7-DD1D2F63D756}"/>
+                <a16:creationId xmlns:a16="http://schemas.microsoft.com/office/drawing/2014/main" id="{F6AFAA75-A9A2-402B-98D1-71321EDDF153}"/>
               </a:ext>
             </a:extLst>
           </p:cNvPr>
@@ -6828,7 +6828,7 @@
           <p:cNvPr id="20" name="">
             <a:extLst xmlns:a="http://schemas.openxmlformats.org/drawingml/2006/main">
               <a:ext uri="{FF2B5EF4-FFF2-40B4-BE49-F238E27FC236}">
-                <a16:creationId xmlns:a16="http://schemas.microsoft.com/office/drawing/2014/main" id="{70C6BDEC-20D7-46D1-A443-501438FAC904}"/>
+                <a16:creationId xmlns:a16="http://schemas.microsoft.com/office/drawing/2014/main" id="{7530A56F-01FD-44E8-AE5E-5A97B1C541F8}"/>
               </a:ext>
             </a:extLst>
           </p:cNvPr>
@@ -6886,7 +6886,7 @@
     </p:spTree>
     <p:extLst>
       <p:ext uri="{BB962C8B-B14F-4D97-AF65-F5344CB8AC3E}">
-        <p14:creationId xmlns:p14="http://schemas.microsoft.com/office/powerpoint/2010/main" val="1510534001"/>
+        <p14:creationId xmlns:p14="http://schemas.microsoft.com/office/powerpoint/2010/main" val="1090728396"/>
       </p:ext>
     </p:extLst>
   </p:cSld>
@@ -6917,7 +6917,7 @@
           <p:cNvPr id="1" name="">
             <a:extLst xmlns:a="http://schemas.openxmlformats.org/drawingml/2006/main">
               <a:ext uri="{FF2B5EF4-FFF2-40B4-BE49-F238E27FC236}">
-                <a16:creationId xmlns:a16="http://schemas.microsoft.com/office/drawing/2014/main" id="{D39F9A5C-1F2D-4CE6-95CD-0853885C0F38}"/>
+                <a16:creationId xmlns:a16="http://schemas.microsoft.com/office/drawing/2014/main" id="{521EFBA7-54E1-47B7-9A5F-070FE9C95237}"/>
               </a:ext>
             </a:extLst>
           </p:cNvPr>
@@ -6977,7 +6977,7 @@
           <p:cNvPr id="2" name="">
             <a:extLst xmlns:a="http://schemas.openxmlformats.org/drawingml/2006/main">
               <a:ext uri="{FF2B5EF4-FFF2-40B4-BE49-F238E27FC236}">
-                <a16:creationId xmlns:a16="http://schemas.microsoft.com/office/drawing/2014/main" id="{708E4564-90E7-470A-B289-9D6C68DD97FF}"/>
+                <a16:creationId xmlns:a16="http://schemas.microsoft.com/office/drawing/2014/main" id="{C02DE51A-4375-406C-9ED0-DA26EFAB96C8}"/>
               </a:ext>
             </a:extLst>
           </p:cNvPr>
@@ -6989,7 +6989,7 @@
         <p:spPr>
           <a:xfrm xmlns:a="http://schemas.openxmlformats.org/drawingml/2006/main">
             <a:off x="400050" y="742950"/>
-            <a:ext cx="8858250" cy="1123950"/>
+            <a:ext cx="8572500" cy="1238250"/>
           </a:xfrm>
           <a:prstGeom xmlns:a="http://schemas.openxmlformats.org/drawingml/2006/main" prst="rect">
             <a:avLst/>
@@ -7006,10 +7006,10 @@
           <a:p xmlns:a="http://schemas.openxmlformats.org/drawingml/2006/main">
             <a:pPr algn="l">
               <a:lnSpc>
-                <a:spcPct val="102000"/>
-              </a:lnSpc>
-              <a:buNone/>
-              <a:defRPr sz="3600" b="1">
+                <a:spcPct val="105000"/>
+              </a:lnSpc>
+              <a:buNone/>
+              <a:defRPr sz="3150" b="1">
                 <a:solidFill>
                   <a:srgbClr val="000000"/>
                 </a:solidFill>
@@ -7019,7 +7019,7 @@
               </a:defRPr>
             </a:pPr>
             <a:r>
-              <a:rPr sz="3600" b="1">
+              <a:rPr sz="3150" b="1">
                 <a:solidFill>
                   <a:srgbClr val="000000"/>
                 </a:solidFill>
@@ -7037,19 +7037,19 @@
           <p:cNvPr id="3" name="">
             <a:extLst xmlns:a="http://schemas.openxmlformats.org/drawingml/2006/main">
               <a:ext uri="{FF2B5EF4-FFF2-40B4-BE49-F238E27FC236}">
-                <a16:creationId xmlns:a16="http://schemas.microsoft.com/office/drawing/2014/main" id="{52420FD3-FC04-4835-AEC2-D214C60329EC}"/>
-              </a:ext>
-            </a:extLst>
-          </p:cNvPr>
-          <p:cNvSpPr>
-            <a:spLocks xmlns:a="http://schemas.openxmlformats.org/drawingml/2006/main" noGrp="1"/>
-          </p:cNvSpPr>
-          <p:nvPr/>
-        </p:nvSpPr>
-        <p:spPr>
-          <a:xfrm xmlns:a="http://schemas.openxmlformats.org/drawingml/2006/main">
-            <a:off x="400050" y="1943100"/>
-            <a:ext cx="7239000" cy="609600"/>
+                <a16:creationId xmlns:a16="http://schemas.microsoft.com/office/drawing/2014/main" id="{EB52B52F-B1D2-437D-9F5C-EBF34BA17A84}"/>
+              </a:ext>
+            </a:extLst>
+          </p:cNvPr>
+          <p:cNvSpPr>
+            <a:spLocks xmlns:a="http://schemas.openxmlformats.org/drawingml/2006/main" noGrp="1"/>
+          </p:cNvSpPr>
+          <p:nvPr/>
+        </p:nvSpPr>
+        <p:spPr>
+          <a:xfrm xmlns:a="http://schemas.openxmlformats.org/drawingml/2006/main">
+            <a:off x="400050" y="2076450"/>
+            <a:ext cx="7620000" cy="590550"/>
           </a:xfrm>
           <a:prstGeom xmlns:a="http://schemas.openxmlformats.org/drawingml/2006/main" prst="rect">
             <a:avLst/>
@@ -7066,20 +7066,20 @@
           <a:p xmlns:a="http://schemas.openxmlformats.org/drawingml/2006/main">
             <a:pPr algn="l">
               <a:lnSpc>
-                <a:spcPct val="125000"/>
-              </a:lnSpc>
-              <a:buNone/>
-              <a:defRPr sz="1650" b="0">
-                <a:solidFill>
-                  <a:srgbClr val="555555"/>
-                </a:solidFill>
-                <a:latin typeface="Malgun Gothic"/>
-                <a:ea typeface="Malgun Gothic"/>
-                <a:cs typeface="Malgun Gothic"/>
-              </a:defRPr>
-            </a:pPr>
-            <a:r>
-              <a:rPr sz="1650" b="0">
+                <a:spcPct val="122000"/>
+              </a:lnSpc>
+              <a:buNone/>
+              <a:defRPr sz="1500" b="0">
+                <a:solidFill>
+                  <a:srgbClr val="555555"/>
+                </a:solidFill>
+                <a:latin typeface="Malgun Gothic"/>
+                <a:ea typeface="Malgun Gothic"/>
+                <a:cs typeface="Malgun Gothic"/>
+              </a:defRPr>
+            </a:pPr>
+            <a:r>
+              <a:rPr sz="1500" b="0">
                 <a:solidFill>
                   <a:srgbClr val="555555"/>
                 </a:solidFill>
@@ -7097,7 +7097,7 @@
           <p:cNvPr id="4" name="">
             <a:extLst xmlns:a="http://schemas.openxmlformats.org/drawingml/2006/main">
               <a:ext uri="{FF2B5EF4-FFF2-40B4-BE49-F238E27FC236}">
-                <a16:creationId xmlns:a16="http://schemas.microsoft.com/office/drawing/2014/main" id="{00740102-7622-426E-965F-AC5DD371DCC3}"/>
+                <a16:creationId xmlns:a16="http://schemas.microsoft.com/office/drawing/2014/main" id="{2349C5ED-CD61-4454-A0C8-4AB69CF8D926}"/>
               </a:ext>
             </a:extLst>
           </p:cNvPr>
@@ -7164,7 +7164,7 @@
         </p:xfrm>
         <a:graphic xmlns:a="http://schemas.openxmlformats.org/drawingml/2006/main">
           <a:graphicData uri="http://schemas.openxmlformats.org/drawingml/2006/chart">
-            <c:chart xmlns:r="http://schemas.openxmlformats.org/officeDocument/2006/relationships" xmlns:c="http://schemas.openxmlformats.org/drawingml/2006/chart" r:id="R440a77950e724636"/>
+            <c:chart xmlns:r="http://schemas.openxmlformats.org/officeDocument/2006/relationships" xmlns:c="http://schemas.openxmlformats.org/drawingml/2006/chart" r:id="R27ca27a962a54823"/>
           </a:graphicData>
         </a:graphic>
       </p:graphicFrame>
@@ -7173,7 +7173,7 @@
           <p:cNvPr id="6" name="">
             <a:extLst xmlns:a="http://schemas.openxmlformats.org/drawingml/2006/main">
               <a:ext uri="{FF2B5EF4-FFF2-40B4-BE49-F238E27FC236}">
-                <a16:creationId xmlns:a16="http://schemas.microsoft.com/office/drawing/2014/main" id="{EA852A0C-B2A4-4283-A4AA-E2F87B895186}"/>
+                <a16:creationId xmlns:a16="http://schemas.microsoft.com/office/drawing/2014/main" id="{D5B5749E-40F6-449E-AB8D-79F258AE3CF4}"/>
               </a:ext>
             </a:extLst>
           </p:cNvPr>
@@ -7204,7 +7204,7 @@
           <p:cNvPr id="7" name="">
             <a:extLst xmlns:a="http://schemas.openxmlformats.org/drawingml/2006/main">
               <a:ext uri="{FF2B5EF4-FFF2-40B4-BE49-F238E27FC236}">
-                <a16:creationId xmlns:a16="http://schemas.microsoft.com/office/drawing/2014/main" id="{B67ACB47-CE5F-424B-8EC7-3952407D852D}"/>
+                <a16:creationId xmlns:a16="http://schemas.microsoft.com/office/drawing/2014/main" id="{B8E178CF-18B6-46F1-8494-5F1E88EA930B}"/>
               </a:ext>
             </a:extLst>
           </p:cNvPr>
@@ -7264,7 +7264,7 @@
           <p:cNvPr id="8" name="">
             <a:extLst xmlns:a="http://schemas.openxmlformats.org/drawingml/2006/main">
               <a:ext uri="{FF2B5EF4-FFF2-40B4-BE49-F238E27FC236}">
-                <a16:creationId xmlns:a16="http://schemas.microsoft.com/office/drawing/2014/main" id="{0082EC7C-55F6-4888-8223-ED4AE430C7F7}"/>
+                <a16:creationId xmlns:a16="http://schemas.microsoft.com/office/drawing/2014/main" id="{4E2BFE2D-A82D-44E8-8E00-E2C2379CDB4D}"/>
               </a:ext>
             </a:extLst>
           </p:cNvPr>
@@ -7324,7 +7324,7 @@
           <p:cNvPr id="9" name="">
             <a:extLst xmlns:a="http://schemas.openxmlformats.org/drawingml/2006/main">
               <a:ext uri="{FF2B5EF4-FFF2-40B4-BE49-F238E27FC236}">
-                <a16:creationId xmlns:a16="http://schemas.microsoft.com/office/drawing/2014/main" id="{017EC36F-DCAE-4F6F-892B-4416B8F58CCD}"/>
+                <a16:creationId xmlns:a16="http://schemas.microsoft.com/office/drawing/2014/main" id="{08475025-9E22-4665-AA0F-E9730F36A30B}"/>
               </a:ext>
             </a:extLst>
           </p:cNvPr>
@@ -7355,7 +7355,7 @@
           <p:cNvPr id="10" name="">
             <a:extLst xmlns:a="http://schemas.openxmlformats.org/drawingml/2006/main">
               <a:ext uri="{FF2B5EF4-FFF2-40B4-BE49-F238E27FC236}">
-                <a16:creationId xmlns:a16="http://schemas.microsoft.com/office/drawing/2014/main" id="{F7A71E92-BA1C-4753-9014-82B9402D8366}"/>
+                <a16:creationId xmlns:a16="http://schemas.microsoft.com/office/drawing/2014/main" id="{6A120156-0F26-4A9A-BA01-A00E8DEDABEB}"/>
               </a:ext>
             </a:extLst>
           </p:cNvPr>
@@ -7415,7 +7415,7 @@
           <p:cNvPr id="11" name="">
             <a:extLst xmlns:a="http://schemas.openxmlformats.org/drawingml/2006/main">
               <a:ext uri="{FF2B5EF4-FFF2-40B4-BE49-F238E27FC236}">
-                <a16:creationId xmlns:a16="http://schemas.microsoft.com/office/drawing/2014/main" id="{DBD6BD72-2F82-463D-81C0-361010D901FD}"/>
+                <a16:creationId xmlns:a16="http://schemas.microsoft.com/office/drawing/2014/main" id="{67B738A9-973B-4B88-8518-F6A1AE1628E9}"/>
               </a:ext>
             </a:extLst>
           </p:cNvPr>
@@ -7475,7 +7475,7 @@
           <p:cNvPr id="12" name="">
             <a:extLst xmlns:a="http://schemas.openxmlformats.org/drawingml/2006/main">
               <a:ext uri="{FF2B5EF4-FFF2-40B4-BE49-F238E27FC236}">
-                <a16:creationId xmlns:a16="http://schemas.microsoft.com/office/drawing/2014/main" id="{3D8E68E0-1660-4A41-A68C-873B993BB0BF}"/>
+                <a16:creationId xmlns:a16="http://schemas.microsoft.com/office/drawing/2014/main" id="{EB99C5FF-E303-4311-A135-7A67B87B0992}"/>
               </a:ext>
             </a:extLst>
           </p:cNvPr>
@@ -7535,7 +7535,7 @@
           <p:cNvPr id="13" name="">
             <a:extLst xmlns:a="http://schemas.openxmlformats.org/drawingml/2006/main">
               <a:ext uri="{FF2B5EF4-FFF2-40B4-BE49-F238E27FC236}">
-                <a16:creationId xmlns:a16="http://schemas.microsoft.com/office/drawing/2014/main" id="{4A75FBD7-E66A-4719-970A-504AC4239A90}"/>
+                <a16:creationId xmlns:a16="http://schemas.microsoft.com/office/drawing/2014/main" id="{6250CF3C-4C41-4E14-A388-F23D12FD65A8}"/>
               </a:ext>
             </a:extLst>
           </p:cNvPr>
@@ -7595,7 +7595,7 @@
           <p:cNvPr id="14" name="">
             <a:extLst xmlns:a="http://schemas.openxmlformats.org/drawingml/2006/main">
               <a:ext uri="{FF2B5EF4-FFF2-40B4-BE49-F238E27FC236}">
-                <a16:creationId xmlns:a16="http://schemas.microsoft.com/office/drawing/2014/main" id="{D00AA595-C44B-4A25-BEBF-13A5E9442E75}"/>
+                <a16:creationId xmlns:a16="http://schemas.microsoft.com/office/drawing/2014/main" id="{EB994B6C-338E-4EE8-851E-CB9AD163706D}"/>
               </a:ext>
             </a:extLst>
           </p:cNvPr>
@@ -7626,7 +7626,7 @@
           <p:cNvPr id="15" name="">
             <a:extLst xmlns:a="http://schemas.openxmlformats.org/drawingml/2006/main">
               <a:ext uri="{FF2B5EF4-FFF2-40B4-BE49-F238E27FC236}">
-                <a16:creationId xmlns:a16="http://schemas.microsoft.com/office/drawing/2014/main" id="{F7B171FA-CDDE-4134-8150-FD2ECDCF679C}"/>
+                <a16:creationId xmlns:a16="http://schemas.microsoft.com/office/drawing/2014/main" id="{6CEE1D5B-0B2A-4A12-98FD-27735B5FE374}"/>
               </a:ext>
             </a:extLst>
           </p:cNvPr>
@@ -7686,7 +7686,7 @@
           <p:cNvPr id="16" name="">
             <a:extLst xmlns:a="http://schemas.openxmlformats.org/drawingml/2006/main">
               <a:ext uri="{FF2B5EF4-FFF2-40B4-BE49-F238E27FC236}">
-                <a16:creationId xmlns:a16="http://schemas.microsoft.com/office/drawing/2014/main" id="{5139237D-3171-4CE0-A934-6326FC4FC201}"/>
+                <a16:creationId xmlns:a16="http://schemas.microsoft.com/office/drawing/2014/main" id="{A86235FA-A886-42AE-99AE-CC30853480C3}"/>
               </a:ext>
             </a:extLst>
           </p:cNvPr>
@@ -7744,7 +7744,7 @@
     </p:spTree>
     <p:extLst>
       <p:ext uri="{BB962C8B-B14F-4D97-AF65-F5344CB8AC3E}">
-        <p14:creationId xmlns:p14="http://schemas.microsoft.com/office/powerpoint/2010/main" val="1470648219"/>
+        <p14:creationId xmlns:p14="http://schemas.microsoft.com/office/powerpoint/2010/main" val="1665129731"/>
       </p:ext>
     </p:extLst>
   </p:cSld>
@@ -7775,7 +7775,7 @@
           <p:cNvPr id="1" name="">
             <a:extLst xmlns:a="http://schemas.openxmlformats.org/drawingml/2006/main">
               <a:ext uri="{FF2B5EF4-FFF2-40B4-BE49-F238E27FC236}">
-                <a16:creationId xmlns:a16="http://schemas.microsoft.com/office/drawing/2014/main" id="{E34E6E58-E656-4B0E-9232-7C9DB262D53D}"/>
+                <a16:creationId xmlns:a16="http://schemas.microsoft.com/office/drawing/2014/main" id="{503C5E28-483A-42A1-9336-60A34DE4E2CF}"/>
               </a:ext>
             </a:extLst>
           </p:cNvPr>
@@ -7835,7 +7835,7 @@
           <p:cNvPr id="2" name="">
             <a:extLst xmlns:a="http://schemas.openxmlformats.org/drawingml/2006/main">
               <a:ext uri="{FF2B5EF4-FFF2-40B4-BE49-F238E27FC236}">
-                <a16:creationId xmlns:a16="http://schemas.microsoft.com/office/drawing/2014/main" id="{F9117240-990F-49C4-BBC1-7F19E97F6D6B}"/>
+                <a16:creationId xmlns:a16="http://schemas.microsoft.com/office/drawing/2014/main" id="{84D5EEC5-F657-4770-9FD5-FBCB614294AA}"/>
               </a:ext>
             </a:extLst>
           </p:cNvPr>
@@ -7847,7 +7847,7 @@
         <p:spPr>
           <a:xfrm xmlns:a="http://schemas.openxmlformats.org/drawingml/2006/main">
             <a:off x="400050" y="742950"/>
-            <a:ext cx="8858250" cy="1123950"/>
+            <a:ext cx="8572500" cy="1238250"/>
           </a:xfrm>
           <a:prstGeom xmlns:a="http://schemas.openxmlformats.org/drawingml/2006/main" prst="rect">
             <a:avLst/>
@@ -7864,10 +7864,10 @@
           <a:p xmlns:a="http://schemas.openxmlformats.org/drawingml/2006/main">
             <a:pPr algn="l">
               <a:lnSpc>
-                <a:spcPct val="102000"/>
-              </a:lnSpc>
-              <a:buNone/>
-              <a:defRPr sz="3600" b="1">
+                <a:spcPct val="105000"/>
+              </a:lnSpc>
+              <a:buNone/>
+              <a:defRPr sz="3150" b="1">
                 <a:solidFill>
                   <a:srgbClr val="000000"/>
                 </a:solidFill>
@@ -7877,7 +7877,7 @@
               </a:defRPr>
             </a:pPr>
             <a:r>
-              <a:rPr sz="3600" b="1">
+              <a:rPr sz="3150" b="1">
                 <a:solidFill>
                   <a:srgbClr val="000000"/>
                 </a:solidFill>
@@ -7895,19 +7895,19 @@
           <p:cNvPr id="3" name="">
             <a:extLst xmlns:a="http://schemas.openxmlformats.org/drawingml/2006/main">
               <a:ext uri="{FF2B5EF4-FFF2-40B4-BE49-F238E27FC236}">
-                <a16:creationId xmlns:a16="http://schemas.microsoft.com/office/drawing/2014/main" id="{8265C17C-F040-4496-9FAE-2CB914F742B7}"/>
-              </a:ext>
-            </a:extLst>
-          </p:cNvPr>
-          <p:cNvSpPr>
-            <a:spLocks xmlns:a="http://schemas.openxmlformats.org/drawingml/2006/main" noGrp="1"/>
-          </p:cNvSpPr>
-          <p:nvPr/>
-        </p:nvSpPr>
-        <p:spPr>
-          <a:xfrm xmlns:a="http://schemas.openxmlformats.org/drawingml/2006/main">
-            <a:off x="400050" y="1943100"/>
-            <a:ext cx="7239000" cy="609600"/>
+                <a16:creationId xmlns:a16="http://schemas.microsoft.com/office/drawing/2014/main" id="{5149D3E9-BBA3-43B2-BBA8-691E083EBAA5}"/>
+              </a:ext>
+            </a:extLst>
+          </p:cNvPr>
+          <p:cNvSpPr>
+            <a:spLocks xmlns:a="http://schemas.openxmlformats.org/drawingml/2006/main" noGrp="1"/>
+          </p:cNvSpPr>
+          <p:nvPr/>
+        </p:nvSpPr>
+        <p:spPr>
+          <a:xfrm xmlns:a="http://schemas.openxmlformats.org/drawingml/2006/main">
+            <a:off x="400050" y="2076450"/>
+            <a:ext cx="7620000" cy="590550"/>
           </a:xfrm>
           <a:prstGeom xmlns:a="http://schemas.openxmlformats.org/drawingml/2006/main" prst="rect">
             <a:avLst/>
@@ -7924,20 +7924,20 @@
           <a:p xmlns:a="http://schemas.openxmlformats.org/drawingml/2006/main">
             <a:pPr algn="l">
               <a:lnSpc>
-                <a:spcPct val="125000"/>
-              </a:lnSpc>
-              <a:buNone/>
-              <a:defRPr sz="1650" b="0">
-                <a:solidFill>
-                  <a:srgbClr val="555555"/>
-                </a:solidFill>
-                <a:latin typeface="Malgun Gothic"/>
-                <a:ea typeface="Malgun Gothic"/>
-                <a:cs typeface="Malgun Gothic"/>
-              </a:defRPr>
-            </a:pPr>
-            <a:r>
-              <a:rPr sz="1650" b="0">
+                <a:spcPct val="122000"/>
+              </a:lnSpc>
+              <a:buNone/>
+              <a:defRPr sz="1500" b="0">
+                <a:solidFill>
+                  <a:srgbClr val="555555"/>
+                </a:solidFill>
+                <a:latin typeface="Malgun Gothic"/>
+                <a:ea typeface="Malgun Gothic"/>
+                <a:cs typeface="Malgun Gothic"/>
+              </a:defRPr>
+            </a:pPr>
+            <a:r>
+              <a:rPr sz="1500" b="0">
                 <a:solidFill>
                   <a:srgbClr val="555555"/>
                 </a:solidFill>
@@ -7955,7 +7955,7 @@
           <p:cNvPr id="4" name="">
             <a:extLst xmlns:a="http://schemas.openxmlformats.org/drawingml/2006/main">
               <a:ext uri="{FF2B5EF4-FFF2-40B4-BE49-F238E27FC236}">
-                <a16:creationId xmlns:a16="http://schemas.microsoft.com/office/drawing/2014/main" id="{0EE2DE81-48C9-418A-BE0C-6BD07DD0E145}"/>
+                <a16:creationId xmlns:a16="http://schemas.microsoft.com/office/drawing/2014/main" id="{1F02B513-EA53-4F20-BED3-DC775D399D44}"/>
               </a:ext>
             </a:extLst>
           </p:cNvPr>
@@ -8015,7 +8015,7 @@
           <p:cNvPr id="5" name="">
             <a:extLst xmlns:a="http://schemas.openxmlformats.org/drawingml/2006/main">
               <a:ext uri="{FF2B5EF4-FFF2-40B4-BE49-F238E27FC236}">
-                <a16:creationId xmlns:a16="http://schemas.microsoft.com/office/drawing/2014/main" id="{5DD46BE7-AD04-439D-A391-4C76C2948228}"/>
+                <a16:creationId xmlns:a16="http://schemas.microsoft.com/office/drawing/2014/main" id="{77FA610A-33FC-46B2-9297-2A80878A230A}"/>
               </a:ext>
             </a:extLst>
           </p:cNvPr>
@@ -8048,7 +8048,7 @@
           <p:cNvPr id="6" name="">
             <a:extLst xmlns:a="http://schemas.openxmlformats.org/drawingml/2006/main">
               <a:ext uri="{FF2B5EF4-FFF2-40B4-BE49-F238E27FC236}">
-                <a16:creationId xmlns:a16="http://schemas.microsoft.com/office/drawing/2014/main" id="{C4859B90-24B5-40B7-AD44-5B733FA3F71A}"/>
+                <a16:creationId xmlns:a16="http://schemas.microsoft.com/office/drawing/2014/main" id="{FFCFBA1F-5F44-49E9-AE1C-CBDF079D5C22}"/>
               </a:ext>
             </a:extLst>
           </p:cNvPr>
@@ -8108,7 +8108,7 @@
           <p:cNvPr id="7" name="">
             <a:extLst xmlns:a="http://schemas.openxmlformats.org/drawingml/2006/main">
               <a:ext uri="{FF2B5EF4-FFF2-40B4-BE49-F238E27FC236}">
-                <a16:creationId xmlns:a16="http://schemas.microsoft.com/office/drawing/2014/main" id="{16B06F6A-3D1D-4444-AD31-759D4BF6F692}"/>
+                <a16:creationId xmlns:a16="http://schemas.microsoft.com/office/drawing/2014/main" id="{2C355407-7005-4529-A301-B929CDFE49DA}"/>
               </a:ext>
             </a:extLst>
           </p:cNvPr>
@@ -8139,7 +8139,7 @@
           <p:cNvPr id="8" name="">
             <a:extLst xmlns:a="http://schemas.openxmlformats.org/drawingml/2006/main">
               <a:ext uri="{FF2B5EF4-FFF2-40B4-BE49-F238E27FC236}">
-                <a16:creationId xmlns:a16="http://schemas.microsoft.com/office/drawing/2014/main" id="{BA71DF50-1F66-4843-9920-6DAC90F6D35F}"/>
+                <a16:creationId xmlns:a16="http://schemas.microsoft.com/office/drawing/2014/main" id="{B47D6E37-E8CF-4646-9F92-3AF858D86D71}"/>
               </a:ext>
             </a:extLst>
           </p:cNvPr>
@@ -8199,7 +8199,7 @@
           <p:cNvPr id="9" name="">
             <a:extLst xmlns:a="http://schemas.openxmlformats.org/drawingml/2006/main">
               <a:ext uri="{FF2B5EF4-FFF2-40B4-BE49-F238E27FC236}">
-                <a16:creationId xmlns:a16="http://schemas.microsoft.com/office/drawing/2014/main" id="{4A4D08CD-46F3-4C92-A022-6F1A236BA216}"/>
+                <a16:creationId xmlns:a16="http://schemas.microsoft.com/office/drawing/2014/main" id="{7E411B48-20CB-4D91-B5A9-8C9355BE4770}"/>
               </a:ext>
             </a:extLst>
           </p:cNvPr>
@@ -8230,7 +8230,7 @@
           <p:cNvPr id="10" name="">
             <a:extLst xmlns:a="http://schemas.openxmlformats.org/drawingml/2006/main">
               <a:ext uri="{FF2B5EF4-FFF2-40B4-BE49-F238E27FC236}">
-                <a16:creationId xmlns:a16="http://schemas.microsoft.com/office/drawing/2014/main" id="{18719280-B543-46C1-9EC6-7BC3FD0740DC}"/>
+                <a16:creationId xmlns:a16="http://schemas.microsoft.com/office/drawing/2014/main" id="{4B23FED6-C575-4BC3-93A4-43548FE0DBC5}"/>
               </a:ext>
             </a:extLst>
           </p:cNvPr>
@@ -8290,7 +8290,7 @@
           <p:cNvPr id="11" name="">
             <a:extLst xmlns:a="http://schemas.openxmlformats.org/drawingml/2006/main">
               <a:ext uri="{FF2B5EF4-FFF2-40B4-BE49-F238E27FC236}">
-                <a16:creationId xmlns:a16="http://schemas.microsoft.com/office/drawing/2014/main" id="{E97919AD-36BF-43EB-A4AA-3A7CA38F9E94}"/>
+                <a16:creationId xmlns:a16="http://schemas.microsoft.com/office/drawing/2014/main" id="{C69AF8E0-272D-4DD7-8F82-A73774BAFAB7}"/>
               </a:ext>
             </a:extLst>
           </p:cNvPr>
@@ -8323,7 +8323,7 @@
           <p:cNvPr id="12" name="">
             <a:extLst xmlns:a="http://schemas.openxmlformats.org/drawingml/2006/main">
               <a:ext uri="{FF2B5EF4-FFF2-40B4-BE49-F238E27FC236}">
-                <a16:creationId xmlns:a16="http://schemas.microsoft.com/office/drawing/2014/main" id="{F99A093C-9A52-4986-ABFE-4F1DF082C54D}"/>
+                <a16:creationId xmlns:a16="http://schemas.microsoft.com/office/drawing/2014/main" id="{7E7272B7-E109-4FD2-A0D3-07A49E36A165}"/>
               </a:ext>
             </a:extLst>
           </p:cNvPr>
@@ -8383,7 +8383,7 @@
           <p:cNvPr id="13" name="">
             <a:extLst xmlns:a="http://schemas.openxmlformats.org/drawingml/2006/main">
               <a:ext uri="{FF2B5EF4-FFF2-40B4-BE49-F238E27FC236}">
-                <a16:creationId xmlns:a16="http://schemas.microsoft.com/office/drawing/2014/main" id="{1AA2F2E1-7267-46C1-A42E-7E82F0FDCDEF}"/>
+                <a16:creationId xmlns:a16="http://schemas.microsoft.com/office/drawing/2014/main" id="{5DAC5AE4-3F63-4197-A87E-E5723FAC7ADA}"/>
               </a:ext>
             </a:extLst>
           </p:cNvPr>
@@ -8414,7 +8414,7 @@
           <p:cNvPr id="14" name="">
             <a:extLst xmlns:a="http://schemas.openxmlformats.org/drawingml/2006/main">
               <a:ext uri="{FF2B5EF4-FFF2-40B4-BE49-F238E27FC236}">
-                <a16:creationId xmlns:a16="http://schemas.microsoft.com/office/drawing/2014/main" id="{0C18CE0C-F6B9-4FD0-9BAA-9ED3DFD58F65}"/>
+                <a16:creationId xmlns:a16="http://schemas.microsoft.com/office/drawing/2014/main" id="{D1F60045-CE69-482C-9834-BEA47F98DBC9}"/>
               </a:ext>
             </a:extLst>
           </p:cNvPr>
@@ -8474,7 +8474,7 @@
           <p:cNvPr id="15" name="">
             <a:extLst xmlns:a="http://schemas.openxmlformats.org/drawingml/2006/main">
               <a:ext uri="{FF2B5EF4-FFF2-40B4-BE49-F238E27FC236}">
-                <a16:creationId xmlns:a16="http://schemas.microsoft.com/office/drawing/2014/main" id="{E61447AF-58F5-4A03-870C-7DAA717792E2}"/>
+                <a16:creationId xmlns:a16="http://schemas.microsoft.com/office/drawing/2014/main" id="{B22B4FE8-B0D3-49A6-B19A-2818EE9E514B}"/>
               </a:ext>
             </a:extLst>
           </p:cNvPr>
@@ -8505,7 +8505,7 @@
           <p:cNvPr id="16" name="">
             <a:extLst xmlns:a="http://schemas.openxmlformats.org/drawingml/2006/main">
               <a:ext uri="{FF2B5EF4-FFF2-40B4-BE49-F238E27FC236}">
-                <a16:creationId xmlns:a16="http://schemas.microsoft.com/office/drawing/2014/main" id="{0D39672B-08C0-4EBC-B4F3-04543DDB0B02}"/>
+                <a16:creationId xmlns:a16="http://schemas.microsoft.com/office/drawing/2014/main" id="{157A94EF-155F-4DBA-9EF4-F8E0515E77AA}"/>
               </a:ext>
             </a:extLst>
           </p:cNvPr>
@@ -8565,7 +8565,7 @@
           <p:cNvPr id="17" name="">
             <a:extLst xmlns:a="http://schemas.openxmlformats.org/drawingml/2006/main">
               <a:ext uri="{FF2B5EF4-FFF2-40B4-BE49-F238E27FC236}">
-                <a16:creationId xmlns:a16="http://schemas.microsoft.com/office/drawing/2014/main" id="{265CE981-9766-466B-88DE-854E86F282CF}"/>
+                <a16:creationId xmlns:a16="http://schemas.microsoft.com/office/drawing/2014/main" id="{49DAD5AC-D672-450D-BE0C-FC666D89B527}"/>
               </a:ext>
             </a:extLst>
           </p:cNvPr>
@@ -8598,7 +8598,7 @@
           <p:cNvPr id="18" name="">
             <a:extLst xmlns:a="http://schemas.openxmlformats.org/drawingml/2006/main">
               <a:ext uri="{FF2B5EF4-FFF2-40B4-BE49-F238E27FC236}">
-                <a16:creationId xmlns:a16="http://schemas.microsoft.com/office/drawing/2014/main" id="{EA7C4FA6-D830-4446-8E26-30B32E5793A4}"/>
+                <a16:creationId xmlns:a16="http://schemas.microsoft.com/office/drawing/2014/main" id="{F27F17F5-85BA-4479-BFF8-4488F8C0A813}"/>
               </a:ext>
             </a:extLst>
           </p:cNvPr>
@@ -8658,7 +8658,7 @@
           <p:cNvPr id="19" name="">
             <a:extLst xmlns:a="http://schemas.openxmlformats.org/drawingml/2006/main">
               <a:ext uri="{FF2B5EF4-FFF2-40B4-BE49-F238E27FC236}">
-                <a16:creationId xmlns:a16="http://schemas.microsoft.com/office/drawing/2014/main" id="{8CEAF7F0-31BB-4B8D-9530-8A10AAF9F119}"/>
+                <a16:creationId xmlns:a16="http://schemas.microsoft.com/office/drawing/2014/main" id="{F97D1B4F-6576-468B-AA82-939FE99D2491}"/>
               </a:ext>
             </a:extLst>
           </p:cNvPr>
@@ -8689,7 +8689,7 @@
           <p:cNvPr id="20" name="">
             <a:extLst xmlns:a="http://schemas.openxmlformats.org/drawingml/2006/main">
               <a:ext uri="{FF2B5EF4-FFF2-40B4-BE49-F238E27FC236}">
-                <a16:creationId xmlns:a16="http://schemas.microsoft.com/office/drawing/2014/main" id="{AD44F088-EA25-44D4-9622-C0267CF10D65}"/>
+                <a16:creationId xmlns:a16="http://schemas.microsoft.com/office/drawing/2014/main" id="{C3A339F7-FA92-456B-9957-58596C013B46}"/>
               </a:ext>
             </a:extLst>
           </p:cNvPr>
@@ -8749,7 +8749,7 @@
           <p:cNvPr id="21" name="">
             <a:extLst xmlns:a="http://schemas.openxmlformats.org/drawingml/2006/main">
               <a:ext uri="{FF2B5EF4-FFF2-40B4-BE49-F238E27FC236}">
-                <a16:creationId xmlns:a16="http://schemas.microsoft.com/office/drawing/2014/main" id="{41279D8D-47E9-44DD-B733-DFA1238C1948}"/>
+                <a16:creationId xmlns:a16="http://schemas.microsoft.com/office/drawing/2014/main" id="{9B34AD0E-EF2B-4069-85AD-43F72EAD78C0}"/>
               </a:ext>
             </a:extLst>
           </p:cNvPr>
@@ -8780,7 +8780,7 @@
           <p:cNvPr id="22" name="">
             <a:extLst xmlns:a="http://schemas.openxmlformats.org/drawingml/2006/main">
               <a:ext uri="{FF2B5EF4-FFF2-40B4-BE49-F238E27FC236}">
-                <a16:creationId xmlns:a16="http://schemas.microsoft.com/office/drawing/2014/main" id="{5DC16208-6E0D-4F15-969C-CC7A1D2E9CD2}"/>
+                <a16:creationId xmlns:a16="http://schemas.microsoft.com/office/drawing/2014/main" id="{04705BAC-A2E5-4305-A532-C89F5537FA05}"/>
               </a:ext>
             </a:extLst>
           </p:cNvPr>
@@ -8840,7 +8840,7 @@
           <p:cNvPr id="23" name="">
             <a:extLst xmlns:a="http://schemas.openxmlformats.org/drawingml/2006/main">
               <a:ext uri="{FF2B5EF4-FFF2-40B4-BE49-F238E27FC236}">
-                <a16:creationId xmlns:a16="http://schemas.microsoft.com/office/drawing/2014/main" id="{11D64D53-54CD-4702-AC89-29B89AE0D968}"/>
+                <a16:creationId xmlns:a16="http://schemas.microsoft.com/office/drawing/2014/main" id="{CCD434C4-6A5C-4978-BBBC-38CBDDF730F3}"/>
               </a:ext>
             </a:extLst>
           </p:cNvPr>
@@ -8873,7 +8873,7 @@
           <p:cNvPr id="24" name="">
             <a:extLst xmlns:a="http://schemas.openxmlformats.org/drawingml/2006/main">
               <a:ext uri="{FF2B5EF4-FFF2-40B4-BE49-F238E27FC236}">
-                <a16:creationId xmlns:a16="http://schemas.microsoft.com/office/drawing/2014/main" id="{B90B39AE-6283-414F-9667-A662E500DD98}"/>
+                <a16:creationId xmlns:a16="http://schemas.microsoft.com/office/drawing/2014/main" id="{94446207-82A3-452A-B294-E6D4777E308A}"/>
               </a:ext>
             </a:extLst>
           </p:cNvPr>
@@ -8933,7 +8933,7 @@
           <p:cNvPr id="25" name="">
             <a:extLst xmlns:a="http://schemas.openxmlformats.org/drawingml/2006/main">
               <a:ext uri="{FF2B5EF4-FFF2-40B4-BE49-F238E27FC236}">
-                <a16:creationId xmlns:a16="http://schemas.microsoft.com/office/drawing/2014/main" id="{CC94D667-EDE3-4FF2-A580-7C45FED16267}"/>
+                <a16:creationId xmlns:a16="http://schemas.microsoft.com/office/drawing/2014/main" id="{9ACF52C0-6804-4E71-9E6A-982B52689865}"/>
               </a:ext>
             </a:extLst>
           </p:cNvPr>
@@ -8964,7 +8964,7 @@
           <p:cNvPr id="26" name="">
             <a:extLst xmlns:a="http://schemas.openxmlformats.org/drawingml/2006/main">
               <a:ext uri="{FF2B5EF4-FFF2-40B4-BE49-F238E27FC236}">
-                <a16:creationId xmlns:a16="http://schemas.microsoft.com/office/drawing/2014/main" id="{69593E5B-4A40-4367-8194-9B2E80C26772}"/>
+                <a16:creationId xmlns:a16="http://schemas.microsoft.com/office/drawing/2014/main" id="{A5F8F838-B390-4D14-821C-522E3F2B818F}"/>
               </a:ext>
             </a:extLst>
           </p:cNvPr>
@@ -9024,7 +9024,7 @@
           <p:cNvPr id="27" name="">
             <a:extLst xmlns:a="http://schemas.openxmlformats.org/drawingml/2006/main">
               <a:ext uri="{FF2B5EF4-FFF2-40B4-BE49-F238E27FC236}">
-                <a16:creationId xmlns:a16="http://schemas.microsoft.com/office/drawing/2014/main" id="{56E02CE3-D328-4155-808C-6AAC0D1AAFAC}"/>
+                <a16:creationId xmlns:a16="http://schemas.microsoft.com/office/drawing/2014/main" id="{E8A255CC-8E82-4A5C-AA76-962294599DFA}"/>
               </a:ext>
             </a:extLst>
           </p:cNvPr>
@@ -9055,7 +9055,7 @@
           <p:cNvPr id="28" name="">
             <a:extLst xmlns:a="http://schemas.openxmlformats.org/drawingml/2006/main">
               <a:ext uri="{FF2B5EF4-FFF2-40B4-BE49-F238E27FC236}">
-                <a16:creationId xmlns:a16="http://schemas.microsoft.com/office/drawing/2014/main" id="{49987056-3A0C-4486-BF68-512B7CA38CB6}"/>
+                <a16:creationId xmlns:a16="http://schemas.microsoft.com/office/drawing/2014/main" id="{EA7F3A21-2CEF-43AF-BE5D-670D2E583074}"/>
               </a:ext>
             </a:extLst>
           </p:cNvPr>
@@ -9115,7 +9115,7 @@
           <p:cNvPr id="29" name="">
             <a:extLst xmlns:a="http://schemas.openxmlformats.org/drawingml/2006/main">
               <a:ext uri="{FF2B5EF4-FFF2-40B4-BE49-F238E27FC236}">
-                <a16:creationId xmlns:a16="http://schemas.microsoft.com/office/drawing/2014/main" id="{DB0EC69A-3AE1-4554-8AC7-44E6631148E3}"/>
+                <a16:creationId xmlns:a16="http://schemas.microsoft.com/office/drawing/2014/main" id="{9AA5E7AA-9BD0-48B9-98E4-0D220CE2052B}"/>
               </a:ext>
             </a:extLst>
           </p:cNvPr>
@@ -9148,7 +9148,7 @@
           <p:cNvPr id="30" name="">
             <a:extLst xmlns:a="http://schemas.openxmlformats.org/drawingml/2006/main">
               <a:ext uri="{FF2B5EF4-FFF2-40B4-BE49-F238E27FC236}">
-                <a16:creationId xmlns:a16="http://schemas.microsoft.com/office/drawing/2014/main" id="{77AAAF62-F3A2-49E5-830A-8B3D86C44B3E}"/>
+                <a16:creationId xmlns:a16="http://schemas.microsoft.com/office/drawing/2014/main" id="{A012EAA6-8A50-46CC-B184-D7AAEB158F74}"/>
               </a:ext>
             </a:extLst>
           </p:cNvPr>
@@ -9208,7 +9208,7 @@
           <p:cNvPr id="31" name="">
             <a:extLst xmlns:a="http://schemas.openxmlformats.org/drawingml/2006/main">
               <a:ext uri="{FF2B5EF4-FFF2-40B4-BE49-F238E27FC236}">
-                <a16:creationId xmlns:a16="http://schemas.microsoft.com/office/drawing/2014/main" id="{AF4C3248-3F2E-4AD7-8A12-A1DBB1B5B802}"/>
+                <a16:creationId xmlns:a16="http://schemas.microsoft.com/office/drawing/2014/main" id="{B9ED006E-7F68-4893-9B76-088757B02F30}"/>
               </a:ext>
             </a:extLst>
           </p:cNvPr>
@@ -9239,7 +9239,7 @@
           <p:cNvPr id="32" name="">
             <a:extLst xmlns:a="http://schemas.openxmlformats.org/drawingml/2006/main">
               <a:ext uri="{FF2B5EF4-FFF2-40B4-BE49-F238E27FC236}">
-                <a16:creationId xmlns:a16="http://schemas.microsoft.com/office/drawing/2014/main" id="{2DB7C25F-8C7E-4808-807B-A2FBB562AD83}"/>
+                <a16:creationId xmlns:a16="http://schemas.microsoft.com/office/drawing/2014/main" id="{86B9BB81-6B6F-4FDD-8C3F-41A42B8F901B}"/>
               </a:ext>
             </a:extLst>
           </p:cNvPr>
@@ -9299,7 +9299,7 @@
           <p:cNvPr id="33" name="">
             <a:extLst xmlns:a="http://schemas.openxmlformats.org/drawingml/2006/main">
               <a:ext uri="{FF2B5EF4-FFF2-40B4-BE49-F238E27FC236}">
-                <a16:creationId xmlns:a16="http://schemas.microsoft.com/office/drawing/2014/main" id="{5F800DA9-4DB2-4858-B1DA-1EAF4B48E25F}"/>
+                <a16:creationId xmlns:a16="http://schemas.microsoft.com/office/drawing/2014/main" id="{1C2640FF-8045-4A38-9F89-5EC0A6D2DAE4}"/>
               </a:ext>
             </a:extLst>
           </p:cNvPr>
@@ -9330,7 +9330,7 @@
           <p:cNvPr id="34" name="">
             <a:extLst xmlns:a="http://schemas.openxmlformats.org/drawingml/2006/main">
               <a:ext uri="{FF2B5EF4-FFF2-40B4-BE49-F238E27FC236}">
-                <a16:creationId xmlns:a16="http://schemas.microsoft.com/office/drawing/2014/main" id="{4F3B1DF1-3419-4387-9CC3-A466379D4FE6}"/>
+                <a16:creationId xmlns:a16="http://schemas.microsoft.com/office/drawing/2014/main" id="{BD6BE439-0DFA-4266-8731-CA3DC94FBA6D}"/>
               </a:ext>
             </a:extLst>
           </p:cNvPr>
@@ -9390,7 +9390,7 @@
           <p:cNvPr id="35" name="">
             <a:extLst xmlns:a="http://schemas.openxmlformats.org/drawingml/2006/main">
               <a:ext uri="{FF2B5EF4-FFF2-40B4-BE49-F238E27FC236}">
-                <a16:creationId xmlns:a16="http://schemas.microsoft.com/office/drawing/2014/main" id="{5C15A4E3-6678-412C-A911-306177F6B681}"/>
+                <a16:creationId xmlns:a16="http://schemas.microsoft.com/office/drawing/2014/main" id="{0C438323-A1BF-43D9-8B41-5F02A7EFC742}"/>
               </a:ext>
             </a:extLst>
           </p:cNvPr>
@@ -9421,7 +9421,7 @@
           <p:cNvPr id="36" name="">
             <a:extLst xmlns:a="http://schemas.openxmlformats.org/drawingml/2006/main">
               <a:ext uri="{FF2B5EF4-FFF2-40B4-BE49-F238E27FC236}">
-                <a16:creationId xmlns:a16="http://schemas.microsoft.com/office/drawing/2014/main" id="{77C49A51-13CA-4111-836C-327DC517E240}"/>
+                <a16:creationId xmlns:a16="http://schemas.microsoft.com/office/drawing/2014/main" id="{12DE23EF-ADF9-43C6-B881-3A0037EED6EF}"/>
               </a:ext>
             </a:extLst>
           </p:cNvPr>
@@ -9481,7 +9481,7 @@
           <p:cNvPr id="37" name="">
             <a:extLst xmlns:a="http://schemas.openxmlformats.org/drawingml/2006/main">
               <a:ext uri="{FF2B5EF4-FFF2-40B4-BE49-F238E27FC236}">
-                <a16:creationId xmlns:a16="http://schemas.microsoft.com/office/drawing/2014/main" id="{7902A972-16CB-49C1-8B01-038E6F4BAAB4}"/>
+                <a16:creationId xmlns:a16="http://schemas.microsoft.com/office/drawing/2014/main" id="{DE502E7D-B176-4C79-9129-38D90ACD7CC6}"/>
               </a:ext>
             </a:extLst>
           </p:cNvPr>
@@ -9539,7 +9539,7 @@
     </p:spTree>
     <p:extLst>
       <p:ext uri="{BB962C8B-B14F-4D97-AF65-F5344CB8AC3E}">
-        <p14:creationId xmlns:p14="http://schemas.microsoft.com/office/powerpoint/2010/main" val="768216896"/>
+        <p14:creationId xmlns:p14="http://schemas.microsoft.com/office/powerpoint/2010/main" val="2001704105"/>
       </p:ext>
     </p:extLst>
   </p:cSld>
@@ -9570,7 +9570,7 @@
           <p:cNvPr id="1" name="">
             <a:extLst xmlns:a="http://schemas.openxmlformats.org/drawingml/2006/main">
               <a:ext uri="{FF2B5EF4-FFF2-40B4-BE49-F238E27FC236}">
-                <a16:creationId xmlns:a16="http://schemas.microsoft.com/office/drawing/2014/main" id="{81308300-313D-4371-B792-D36C4393100D}"/>
+                <a16:creationId xmlns:a16="http://schemas.microsoft.com/office/drawing/2014/main" id="{2FF0B34D-578E-4C46-9909-6B5F80681289}"/>
               </a:ext>
             </a:extLst>
           </p:cNvPr>
@@ -9630,7 +9630,7 @@
           <p:cNvPr id="2" name="">
             <a:extLst xmlns:a="http://schemas.openxmlformats.org/drawingml/2006/main">
               <a:ext uri="{FF2B5EF4-FFF2-40B4-BE49-F238E27FC236}">
-                <a16:creationId xmlns:a16="http://schemas.microsoft.com/office/drawing/2014/main" id="{E5EFD444-A6FA-4D6D-8866-B672FDC541FB}"/>
+                <a16:creationId xmlns:a16="http://schemas.microsoft.com/office/drawing/2014/main" id="{240D70A0-CB96-48DD-BCB9-742754E4929F}"/>
               </a:ext>
             </a:extLst>
           </p:cNvPr>
@@ -9642,7 +9642,7 @@
         <p:spPr>
           <a:xfrm xmlns:a="http://schemas.openxmlformats.org/drawingml/2006/main">
             <a:off x="400050" y="742950"/>
-            <a:ext cx="8858250" cy="1123950"/>
+            <a:ext cx="8572500" cy="1238250"/>
           </a:xfrm>
           <a:prstGeom xmlns:a="http://schemas.openxmlformats.org/drawingml/2006/main" prst="rect">
             <a:avLst/>
@@ -9659,10 +9659,10 @@
           <a:p xmlns:a="http://schemas.openxmlformats.org/drawingml/2006/main">
             <a:pPr algn="l">
               <a:lnSpc>
-                <a:spcPct val="102000"/>
-              </a:lnSpc>
-              <a:buNone/>
-              <a:defRPr sz="3600" b="1">
+                <a:spcPct val="105000"/>
+              </a:lnSpc>
+              <a:buNone/>
+              <a:defRPr sz="3150" b="1">
                 <a:solidFill>
                   <a:srgbClr val="000000"/>
                 </a:solidFill>
@@ -9672,7 +9672,7 @@
               </a:defRPr>
             </a:pPr>
             <a:r>
-              <a:rPr sz="3600" b="1">
+              <a:rPr sz="3150" b="1">
                 <a:solidFill>
                   <a:srgbClr val="000000"/>
                 </a:solidFill>
@@ -9690,19 +9690,19 @@
           <p:cNvPr id="3" name="">
             <a:extLst xmlns:a="http://schemas.openxmlformats.org/drawingml/2006/main">
               <a:ext uri="{FF2B5EF4-FFF2-40B4-BE49-F238E27FC236}">
-                <a16:creationId xmlns:a16="http://schemas.microsoft.com/office/drawing/2014/main" id="{D7F40E15-D939-4333-B83E-7A957C2062CD}"/>
-              </a:ext>
-            </a:extLst>
-          </p:cNvPr>
-          <p:cNvSpPr>
-            <a:spLocks xmlns:a="http://schemas.openxmlformats.org/drawingml/2006/main" noGrp="1"/>
-          </p:cNvSpPr>
-          <p:nvPr/>
-        </p:nvSpPr>
-        <p:spPr>
-          <a:xfrm xmlns:a="http://schemas.openxmlformats.org/drawingml/2006/main">
-            <a:off x="400050" y="1943100"/>
-            <a:ext cx="7239000" cy="609600"/>
+                <a16:creationId xmlns:a16="http://schemas.microsoft.com/office/drawing/2014/main" id="{556026C1-191A-4060-BF0F-8E2B250C27EF}"/>
+              </a:ext>
+            </a:extLst>
+          </p:cNvPr>
+          <p:cNvSpPr>
+            <a:spLocks xmlns:a="http://schemas.openxmlformats.org/drawingml/2006/main" noGrp="1"/>
+          </p:cNvSpPr>
+          <p:nvPr/>
+        </p:nvSpPr>
+        <p:spPr>
+          <a:xfrm xmlns:a="http://schemas.openxmlformats.org/drawingml/2006/main">
+            <a:off x="400050" y="2076450"/>
+            <a:ext cx="7620000" cy="590550"/>
           </a:xfrm>
           <a:prstGeom xmlns:a="http://schemas.openxmlformats.org/drawingml/2006/main" prst="rect">
             <a:avLst/>
@@ -9719,20 +9719,20 @@
           <a:p xmlns:a="http://schemas.openxmlformats.org/drawingml/2006/main">
             <a:pPr algn="l">
               <a:lnSpc>
-                <a:spcPct val="125000"/>
-              </a:lnSpc>
-              <a:buNone/>
-              <a:defRPr sz="1650" b="0">
-                <a:solidFill>
-                  <a:srgbClr val="555555"/>
-                </a:solidFill>
-                <a:latin typeface="Malgun Gothic"/>
-                <a:ea typeface="Malgun Gothic"/>
-                <a:cs typeface="Malgun Gothic"/>
-              </a:defRPr>
-            </a:pPr>
-            <a:r>
-              <a:rPr sz="1650" b="0">
+                <a:spcPct val="122000"/>
+              </a:lnSpc>
+              <a:buNone/>
+              <a:defRPr sz="1500" b="0">
+                <a:solidFill>
+                  <a:srgbClr val="555555"/>
+                </a:solidFill>
+                <a:latin typeface="Malgun Gothic"/>
+                <a:ea typeface="Malgun Gothic"/>
+                <a:cs typeface="Malgun Gothic"/>
+              </a:defRPr>
+            </a:pPr>
+            <a:r>
+              <a:rPr sz="1500" b="0">
                 <a:solidFill>
                   <a:srgbClr val="555555"/>
                 </a:solidFill>
@@ -9750,7 +9750,7 @@
           <p:cNvPr id="4" name="">
             <a:extLst xmlns:a="http://schemas.openxmlformats.org/drawingml/2006/main">
               <a:ext uri="{FF2B5EF4-FFF2-40B4-BE49-F238E27FC236}">
-                <a16:creationId xmlns:a16="http://schemas.microsoft.com/office/drawing/2014/main" id="{C260959A-6986-4CAA-9EBF-BE3C576AC126}"/>
+                <a16:creationId xmlns:a16="http://schemas.microsoft.com/office/drawing/2014/main" id="{CB4AA190-94F4-48A4-B85B-EB0B21617F28}"/>
               </a:ext>
             </a:extLst>
           </p:cNvPr>
@@ -9810,7 +9810,7 @@
           <p:cNvPr id="5" name="">
             <a:extLst xmlns:a="http://schemas.openxmlformats.org/drawingml/2006/main">
               <a:ext uri="{FF2B5EF4-FFF2-40B4-BE49-F238E27FC236}">
-                <a16:creationId xmlns:a16="http://schemas.microsoft.com/office/drawing/2014/main" id="{7FB82E17-5198-47EB-AA2F-423EDF281FB2}"/>
+                <a16:creationId xmlns:a16="http://schemas.microsoft.com/office/drawing/2014/main" id="{6E79FB0A-4C61-410B-8CF2-D95B6CED4E97}"/>
               </a:ext>
             </a:extLst>
           </p:cNvPr>
@@ -9841,7 +9841,7 @@
           <p:cNvPr id="6" name="">
             <a:extLst xmlns:a="http://schemas.openxmlformats.org/drawingml/2006/main">
               <a:ext uri="{FF2B5EF4-FFF2-40B4-BE49-F238E27FC236}">
-                <a16:creationId xmlns:a16="http://schemas.microsoft.com/office/drawing/2014/main" id="{171D90F0-002B-4C14-8D9C-B0467ADD9FB5}"/>
+                <a16:creationId xmlns:a16="http://schemas.microsoft.com/office/drawing/2014/main" id="{1E280748-1C2A-4B67-A288-93A953664F0F}"/>
               </a:ext>
             </a:extLst>
           </p:cNvPr>
@@ -9901,7 +9901,7 @@
           <p:cNvPr id="7" name="">
             <a:extLst xmlns:a="http://schemas.openxmlformats.org/drawingml/2006/main">
               <a:ext uri="{FF2B5EF4-FFF2-40B4-BE49-F238E27FC236}">
-                <a16:creationId xmlns:a16="http://schemas.microsoft.com/office/drawing/2014/main" id="{B0333AE2-CD66-4311-ABC1-37B64DAD8D44}"/>
+                <a16:creationId xmlns:a16="http://schemas.microsoft.com/office/drawing/2014/main" id="{B4155CE7-D7BE-48C4-9510-36E714B59E3A}"/>
               </a:ext>
             </a:extLst>
           </p:cNvPr>
@@ -9961,7 +9961,7 @@
           <p:cNvPr id="8" name="">
             <a:extLst xmlns:a="http://schemas.openxmlformats.org/drawingml/2006/main">
               <a:ext uri="{FF2B5EF4-FFF2-40B4-BE49-F238E27FC236}">
-                <a16:creationId xmlns:a16="http://schemas.microsoft.com/office/drawing/2014/main" id="{9A0744A6-30BC-4558-A60D-691C8A202541}"/>
+                <a16:creationId xmlns:a16="http://schemas.microsoft.com/office/drawing/2014/main" id="{EF17AB41-E148-4A15-9976-E953EC836BAF}"/>
               </a:ext>
             </a:extLst>
           </p:cNvPr>
@@ -9992,7 +9992,7 @@
           <p:cNvPr id="9" name="">
             <a:extLst xmlns:a="http://schemas.openxmlformats.org/drawingml/2006/main">
               <a:ext uri="{FF2B5EF4-FFF2-40B4-BE49-F238E27FC236}">
-                <a16:creationId xmlns:a16="http://schemas.microsoft.com/office/drawing/2014/main" id="{A6A08E10-2C0E-4D81-87C5-C7EA2128A0D1}"/>
+                <a16:creationId xmlns:a16="http://schemas.microsoft.com/office/drawing/2014/main" id="{06C5807E-1237-423F-9F06-53C77336B0CF}"/>
               </a:ext>
             </a:extLst>
           </p:cNvPr>
@@ -10052,7 +10052,7 @@
           <p:cNvPr id="10" name="">
             <a:extLst xmlns:a="http://schemas.openxmlformats.org/drawingml/2006/main">
               <a:ext uri="{FF2B5EF4-FFF2-40B4-BE49-F238E27FC236}">
-                <a16:creationId xmlns:a16="http://schemas.microsoft.com/office/drawing/2014/main" id="{3AEAFA49-408C-46C2-96AE-4E2A8A021D33}"/>
+                <a16:creationId xmlns:a16="http://schemas.microsoft.com/office/drawing/2014/main" id="{D6DB51B0-B2BA-4B8A-A604-155A13F124DD}"/>
               </a:ext>
             </a:extLst>
           </p:cNvPr>
@@ -10112,7 +10112,7 @@
           <p:cNvPr id="11" name="">
             <a:extLst xmlns:a="http://schemas.openxmlformats.org/drawingml/2006/main">
               <a:ext uri="{FF2B5EF4-FFF2-40B4-BE49-F238E27FC236}">
-                <a16:creationId xmlns:a16="http://schemas.microsoft.com/office/drawing/2014/main" id="{8114C225-0488-4945-8B9B-8344831FD78F}"/>
+                <a16:creationId xmlns:a16="http://schemas.microsoft.com/office/drawing/2014/main" id="{3AF1F0B1-6A0F-4A6C-A633-791BEC9A6F86}"/>
               </a:ext>
             </a:extLst>
           </p:cNvPr>
@@ -10143,7 +10143,7 @@
           <p:cNvPr id="12" name="">
             <a:extLst xmlns:a="http://schemas.openxmlformats.org/drawingml/2006/main">
               <a:ext uri="{FF2B5EF4-FFF2-40B4-BE49-F238E27FC236}">
-                <a16:creationId xmlns:a16="http://schemas.microsoft.com/office/drawing/2014/main" id="{15D5B239-12D4-44E2-8007-D35BE2FC5D0E}"/>
+                <a16:creationId xmlns:a16="http://schemas.microsoft.com/office/drawing/2014/main" id="{C0B5A739-859E-4689-BB96-C43A5973D50B}"/>
               </a:ext>
             </a:extLst>
           </p:cNvPr>
@@ -10203,7 +10203,7 @@
           <p:cNvPr id="13" name="">
             <a:extLst xmlns:a="http://schemas.openxmlformats.org/drawingml/2006/main">
               <a:ext uri="{FF2B5EF4-FFF2-40B4-BE49-F238E27FC236}">
-                <a16:creationId xmlns:a16="http://schemas.microsoft.com/office/drawing/2014/main" id="{B89830E7-8C28-4A6A-923F-C7A2AC264CA3}"/>
+                <a16:creationId xmlns:a16="http://schemas.microsoft.com/office/drawing/2014/main" id="{0D0F70D2-01EA-4CD9-A7AA-8D6B59EB080C}"/>
               </a:ext>
             </a:extLst>
           </p:cNvPr>
@@ -10263,7 +10263,7 @@
           <p:cNvPr id="14" name="">
             <a:extLst xmlns:a="http://schemas.openxmlformats.org/drawingml/2006/main">
               <a:ext uri="{FF2B5EF4-FFF2-40B4-BE49-F238E27FC236}">
-                <a16:creationId xmlns:a16="http://schemas.microsoft.com/office/drawing/2014/main" id="{90625031-5545-484A-BB1B-3AC4FB8EED65}"/>
+                <a16:creationId xmlns:a16="http://schemas.microsoft.com/office/drawing/2014/main" id="{9CB6013D-1E68-4885-980F-863C5EC2CAD0}"/>
               </a:ext>
             </a:extLst>
           </p:cNvPr>
@@ -10275,7 +10275,7 @@
         <p:spPr>
           <a:xfrm xmlns:a="http://schemas.openxmlformats.org/drawingml/2006/main">
             <a:off x="1219200" y="5334000"/>
-            <a:ext cx="9715500" cy="400050"/>
+            <a:ext cx="9715500" cy="457200"/>
           </a:xfrm>
           <a:prstGeom xmlns:a="http://schemas.openxmlformats.org/drawingml/2006/main" prst="rect">
             <a:avLst/>
@@ -10295,7 +10295,7 @@
                 <a:spcPct val="112000"/>
               </a:lnSpc>
               <a:buNone/>
-              <a:defRPr sz="2250" b="1">
+              <a:defRPr sz="1950" b="1">
                 <a:solidFill>
                   <a:srgbClr val="000000"/>
                 </a:solidFill>
@@ -10305,7 +10305,7 @@
               </a:defRPr>
             </a:pPr>
             <a:r>
-              <a:rPr sz="2250" b="1">
+              <a:rPr sz="1950" b="1">
                 <a:solidFill>
                   <a:srgbClr val="000000"/>
                 </a:solidFill>
@@ -10323,7 +10323,7 @@
           <p:cNvPr id="15" name="">
             <a:extLst xmlns:a="http://schemas.openxmlformats.org/drawingml/2006/main">
               <a:ext uri="{FF2B5EF4-FFF2-40B4-BE49-F238E27FC236}">
-                <a16:creationId xmlns:a16="http://schemas.microsoft.com/office/drawing/2014/main" id="{38061B70-AD3D-4E9C-A195-DF53D5C2C48E}"/>
+                <a16:creationId xmlns:a16="http://schemas.microsoft.com/office/drawing/2014/main" id="{0EB42AFC-B2E4-4275-8721-3148D93AC413}"/>
               </a:ext>
             </a:extLst>
           </p:cNvPr>
@@ -10354,7 +10354,7 @@
           <p:cNvPr id="16" name="">
             <a:extLst xmlns:a="http://schemas.openxmlformats.org/drawingml/2006/main">
               <a:ext uri="{FF2B5EF4-FFF2-40B4-BE49-F238E27FC236}">
-                <a16:creationId xmlns:a16="http://schemas.microsoft.com/office/drawing/2014/main" id="{58BE85BE-1E77-468E-8EA8-F220316F3F37}"/>
+                <a16:creationId xmlns:a16="http://schemas.microsoft.com/office/drawing/2014/main" id="{B4B71F1C-7D73-4A11-9CE9-82F5505E1742}"/>
               </a:ext>
             </a:extLst>
           </p:cNvPr>
@@ -10414,7 +10414,7 @@
           <p:cNvPr id="17" name="">
             <a:extLst xmlns:a="http://schemas.openxmlformats.org/drawingml/2006/main">
               <a:ext uri="{FF2B5EF4-FFF2-40B4-BE49-F238E27FC236}">
-                <a16:creationId xmlns:a16="http://schemas.microsoft.com/office/drawing/2014/main" id="{EEE2E017-96FB-44FB-BBA0-22292A07DF65}"/>
+                <a16:creationId xmlns:a16="http://schemas.microsoft.com/office/drawing/2014/main" id="{8D1696D4-5438-4C17-B10F-5AF83295C8ED}"/>
               </a:ext>
             </a:extLst>
           </p:cNvPr>
@@ -10472,7 +10472,7 @@
     </p:spTree>
     <p:extLst>
       <p:ext uri="{BB962C8B-B14F-4D97-AF65-F5344CB8AC3E}">
-        <p14:creationId xmlns:p14="http://schemas.microsoft.com/office/powerpoint/2010/main" val="1863675690"/>
+        <p14:creationId xmlns:p14="http://schemas.microsoft.com/office/powerpoint/2010/main" val="557607530"/>
       </p:ext>
     </p:extLst>
   </p:cSld>

</xml_diff>